<commit_message>
Sync Claude-Sehari-Hari slide deck with locally edited version
</commit_message>
<xml_diff>
--- a/Claude-Sehari-Hari/Course-Level/Claude-Sehari-Hari-Slide-Deck.pptx
+++ b/Claude-Sehari-Hari/Course-Level/Claude-Sehari-Hari-Slide-Deck.pptx
@@ -4,6 +4,9 @@
   <p:sldMasterIdLst>
     <p:sldMasterId id="2147483648" r:id="rId1"/>
   </p:sldMasterIdLst>
+  <p:notesMasterIdLst>
+    <p:notesMasterId r:id="rId16"/>
+  </p:notesMasterIdLst>
   <p:sldIdLst>
     <p:sldId id="256" r:id="rId2"/>
     <p:sldId id="257" r:id="rId3"/>
@@ -20,11 +23,8 @@
     <p:sldId id="268" r:id="rId14"/>
     <p:sldId id="269" r:id="rId15"/>
   </p:sldIdLst>
-  <p:notesMasterIdLst>
-    <p:notesMasterId r:id="rId16"/>
-  </p:notesMasterIdLst>
-  <p:sldSz cx="12191695" cy="6858000"/>
-  <p:notesSz cx="6858000" cy="12191695"/>
+  <p:sldSz cx="12192000" cy="6858000"/>
+  <p:notesSz cx="6858000" cy="12192000"/>
   <p:defaultTextStyle>
     <a:lvl1pPr marL="0" algn="l" defTabSz="914400" rtl="0" eaLnBrk="1" latinLnBrk="0" hangingPunct="1">
       <a:defRPr sz="1800" kern="1200">
@@ -117,6 +117,11 @@
       </a:defRPr>
     </a:lvl9pPr>
   </p:defaultTextStyle>
+  <p:extLst>
+    <p:ext uri="{EFAFB233-063F-42B5-8137-9DF3F51BA10A}">
+      <p15:sldGuideLst xmlns:p15="http://schemas.microsoft.com/office/powerpoint/2012/main"/>
+    </p:ext>
+  </p:extLst>
 </p:presentation>
 </file>
 
@@ -142,234 +147,10 @@
           <a:chExt cx="0" cy="0"/>
         </a:xfrm>
       </p:grpSpPr>
-      <p:sp>
-        <p:nvSpPr>
-          <p:cNvPr id="2" name="Header Placeholder 1"/>
-          <p:cNvSpPr>
-            <a:spLocks noGrp="1"/>
-          </p:cNvSpPr>
-          <p:nvPr>
-            <p:ph type="hdr" sz="quarter"/>
-          </p:nvPr>
-        </p:nvSpPr>
-        <p:spPr>
-          <a:xfrm>
-            <a:off x="0" y="0"/>
-            <a:ext cx="2971800" cy="458788"/>
-          </a:xfrm>
-          <a:prstGeom prst="rect">
-            <a:avLst/>
-          </a:prstGeom>
-        </p:spPr>
-        <p:txBody>
-          <a:bodyPr vert="horz" lIns="91440" tIns="45720" rIns="91440" bIns="45720" rtlCol="0"/>
-          <a:lstStyle>
-            <a:lvl1pPr algn="l">
-              <a:defRPr sz="1200"/>
-            </a:lvl1pPr>
-          </a:lstStyle>
-          <a:p>
-            <a:endParaRPr lang="en-US"/>
-          </a:p>
-        </p:txBody>
-      </p:sp>
-      <p:sp>
-        <p:nvSpPr>
-          <p:cNvPr id="3" name="Date Placeholder 2"/>
-          <p:cNvSpPr>
-            <a:spLocks noGrp="1"/>
-          </p:cNvSpPr>
-          <p:nvPr>
-            <p:ph type="dt" idx="1"/>
-          </p:nvPr>
-        </p:nvSpPr>
-        <p:spPr>
-          <a:xfrm>
-            <a:off x="3884613" y="0"/>
-            <a:ext cx="2971800" cy="458788"/>
-          </a:xfrm>
-          <a:prstGeom prst="rect">
-            <a:avLst/>
-          </a:prstGeom>
-        </p:spPr>
-        <p:txBody>
-          <a:bodyPr vert="horz" lIns="91440" tIns="45720" rIns="91440" bIns="45720" rtlCol="0"/>
-          <a:lstStyle>
-            <a:lvl1pPr algn="r">
-              <a:defRPr sz="1200"/>
-            </a:lvl1pPr>
-          </a:lstStyle>
-          <a:p>
-            <a:fld id="{5282F153-3F37-0F45-9E97-73ACFA13230C}" type="datetimeFigureOut">
-              <a:rPr lang="en-US"/>
-              <a:t>7/23/19</a:t>
-            </a:fld>
-            <a:endParaRPr lang="en-US"/>
-          </a:p>
-        </p:txBody>
-      </p:sp>
-      <p:sp>
-        <p:nvSpPr>
-          <p:cNvPr id="4" name="Slide Image Placeholder 3"/>
-          <p:cNvSpPr>
-            <a:spLocks noGrp="1" noRot="1" noChangeAspect="1"/>
-          </p:cNvSpPr>
-          <p:nvPr>
-            <p:ph type="sldImg" idx="2"/>
-          </p:nvPr>
-        </p:nvSpPr>
-        <p:spPr>
-          <a:xfrm>
-            <a:off x="685800" y="1143000"/>
-            <a:ext cx="5486400" cy="3086100"/>
-          </a:xfrm>
-          <a:prstGeom prst="rect">
-            <a:avLst/>
-          </a:prstGeom>
-          <a:noFill/>
-          <a:ln w="12700">
-            <a:solidFill>
-              <a:prstClr val="black"/>
-            </a:solidFill>
-          </a:ln>
-        </p:spPr>
-        <p:txBody>
-          <a:bodyPr vert="horz" lIns="91440" tIns="45720" rIns="91440" bIns="45720" rtlCol="0" anchor="ctr"/>
-          <a:lstStyle/>
-          <a:p>
-            <a:endParaRPr lang="en-US"/>
-          </a:p>
-        </p:txBody>
-      </p:sp>
-      <p:sp>
-        <p:nvSpPr>
-          <p:cNvPr id="5" name="Notes Placeholder 4"/>
-          <p:cNvSpPr>
-            <a:spLocks noGrp="1"/>
-          </p:cNvSpPr>
-          <p:nvPr>
-            <p:ph type="body" sz="quarter" idx="3"/>
-          </p:nvPr>
-        </p:nvSpPr>
-        <p:spPr>
-          <a:xfrm>
-            <a:off x="685800" y="4400550"/>
-            <a:ext cx="5486400" cy="3600450"/>
-          </a:xfrm>
-          <a:prstGeom prst="rect">
-            <a:avLst/>
-          </a:prstGeom>
-        </p:spPr>
-        <p:txBody>
-          <a:bodyPr vert="horz" lIns="91440" tIns="45720" rIns="91440" bIns="45720" rtlCol="0"/>
-          <a:lstStyle/>
-          <a:p>
-            <a:pPr lvl="0"/>
-            <a:r>
-              <a:rPr lang="en-US"/>
-              <a:t>Click to edit Master text styles</a:t>
-            </a:r>
-          </a:p>
-          <a:p>
-            <a:pPr lvl="1"/>
-            <a:r>
-              <a:rPr lang="en-US"/>
-              <a:t>Second level</a:t>
-            </a:r>
-          </a:p>
-          <a:p>
-            <a:pPr lvl="2"/>
-            <a:r>
-              <a:rPr lang="en-US"/>
-              <a:t>Third level</a:t>
-            </a:r>
-          </a:p>
-          <a:p>
-            <a:pPr lvl="3"/>
-            <a:r>
-              <a:rPr lang="en-US"/>
-              <a:t>Fourth level</a:t>
-            </a:r>
-          </a:p>
-          <a:p>
-            <a:pPr lvl="4"/>
-            <a:r>
-              <a:rPr lang="en-US"/>
-              <a:t>Fifth level</a:t>
-            </a:r>
-          </a:p>
-        </p:txBody>
-      </p:sp>
-      <p:sp>
-        <p:nvSpPr>
-          <p:cNvPr id="6" name="Footer Placeholder 5"/>
-          <p:cNvSpPr>
-            <a:spLocks noGrp="1"/>
-          </p:cNvSpPr>
-          <p:nvPr>
-            <p:ph type="ftr" sz="quarter" idx="4"/>
-          </p:nvPr>
-        </p:nvSpPr>
-        <p:spPr>
-          <a:xfrm>
-            <a:off x="0" y="8685213"/>
-            <a:ext cx="2971800" cy="458787"/>
-          </a:xfrm>
-          <a:prstGeom prst="rect">
-            <a:avLst/>
-          </a:prstGeom>
-        </p:spPr>
-        <p:txBody>
-          <a:bodyPr vert="horz" lIns="91440" tIns="45720" rIns="91440" bIns="45720" rtlCol="0" anchor="b"/>
-          <a:lstStyle>
-            <a:lvl1pPr algn="l">
-              <a:defRPr sz="1200"/>
-            </a:lvl1pPr>
-          </a:lstStyle>
-          <a:p>
-            <a:endParaRPr lang="en-US"/>
-          </a:p>
-        </p:txBody>
-      </p:sp>
-      <p:sp>
-        <p:nvSpPr>
-          <p:cNvPr id="7" name="Slide Number Placeholder 6"/>
-          <p:cNvSpPr>
-            <a:spLocks noGrp="1"/>
-          </p:cNvSpPr>
-          <p:nvPr>
-            <p:ph type="sldNum" sz="quarter" idx="5"/>
-          </p:nvPr>
-        </p:nvSpPr>
-        <p:spPr>
-          <a:xfrm>
-            <a:off x="3884613" y="8685213"/>
-            <a:ext cx="2971800" cy="458787"/>
-          </a:xfrm>
-          <a:prstGeom prst="rect">
-            <a:avLst/>
-          </a:prstGeom>
-        </p:spPr>
-        <p:txBody>
-          <a:bodyPr vert="horz" lIns="91440" tIns="45720" rIns="91440" bIns="45720" rtlCol="0" anchor="b"/>
-          <a:lstStyle>
-            <a:lvl1pPr algn="r">
-              <a:defRPr sz="1200"/>
-            </a:lvl1pPr>
-          </a:lstStyle>
-          <a:p>
-            <a:fld id="{CE5E9CC1-C706-0F49-92D6-E571CC5EEA8F}" type="slidenum">
-              <a:rPr lang="en-US"/>
-              <a:t>‹#›</a:t>
-            </a:fld>
-            <a:endParaRPr lang="en-US"/>
-          </a:p>
-        </p:txBody>
-      </p:sp>
     </p:spTree>
     <p:extLst>
       <p:ext uri="{BB962C8B-B14F-4D97-AF65-F5344CB8AC3E}">
-        <p14:creationId xmlns:p14="http://schemas.microsoft.com/office/powerpoint/2010/main" val="1024086991"/>
+        <p14:creationId xmlns:p14="http://schemas.microsoft.com/office/powerpoint/2010/main" val="3959023444"/>
       </p:ext>
     </p:extLst>
   </p:cSld>
@@ -513,10 +294,6 @@
           <a:bodyPr/>
           <a:lstStyle/>
           <a:p>
-            <a:r>
-              <a:rPr lang="en-US" dirty="0"/>
-              <a:t/>
-            </a:r>
             <a:endParaRPr lang="en-US" dirty="0"/>
           </a:p>
         </p:txBody>
@@ -601,10 +378,6 @@
           <a:bodyPr/>
           <a:lstStyle/>
           <a:p>
-            <a:r>
-              <a:rPr lang="en-US" dirty="0"/>
-              <a:t/>
-            </a:r>
             <a:endParaRPr lang="en-US" dirty="0"/>
           </a:p>
         </p:txBody>
@@ -689,10 +462,6 @@
           <a:bodyPr/>
           <a:lstStyle/>
           <a:p>
-            <a:r>
-              <a:rPr lang="en-US" dirty="0"/>
-              <a:t/>
-            </a:r>
             <a:endParaRPr lang="en-US" dirty="0"/>
           </a:p>
         </p:txBody>
@@ -777,10 +546,6 @@
           <a:bodyPr/>
           <a:lstStyle/>
           <a:p>
-            <a:r>
-              <a:rPr lang="en-US" dirty="0"/>
-              <a:t/>
-            </a:r>
             <a:endParaRPr lang="en-US" dirty="0"/>
           </a:p>
         </p:txBody>
@@ -865,10 +630,6 @@
           <a:bodyPr/>
           <a:lstStyle/>
           <a:p>
-            <a:r>
-              <a:rPr lang="en-US" dirty="0"/>
-              <a:t/>
-            </a:r>
             <a:endParaRPr lang="en-US" dirty="0"/>
           </a:p>
         </p:txBody>
@@ -953,10 +714,6 @@
           <a:bodyPr/>
           <a:lstStyle/>
           <a:p>
-            <a:r>
-              <a:rPr lang="en-US" dirty="0"/>
-              <a:t/>
-            </a:r>
             <a:endParaRPr lang="en-US" dirty="0"/>
           </a:p>
         </p:txBody>
@@ -1041,10 +798,6 @@
           <a:bodyPr/>
           <a:lstStyle/>
           <a:p>
-            <a:r>
-              <a:rPr lang="en-US" dirty="0"/>
-              <a:t/>
-            </a:r>
             <a:endParaRPr lang="en-US" dirty="0"/>
           </a:p>
         </p:txBody>
@@ -1129,10 +882,6 @@
           <a:bodyPr/>
           <a:lstStyle/>
           <a:p>
-            <a:r>
-              <a:rPr lang="en-US" dirty="0"/>
-              <a:t/>
-            </a:r>
             <a:endParaRPr lang="en-US" dirty="0"/>
           </a:p>
         </p:txBody>
@@ -1217,10 +966,6 @@
           <a:bodyPr/>
           <a:lstStyle/>
           <a:p>
-            <a:r>
-              <a:rPr lang="en-US" dirty="0"/>
-              <a:t/>
-            </a:r>
             <a:endParaRPr lang="en-US" dirty="0"/>
           </a:p>
         </p:txBody>
@@ -1305,10 +1050,6 @@
           <a:bodyPr/>
           <a:lstStyle/>
           <a:p>
-            <a:r>
-              <a:rPr lang="en-US" dirty="0"/>
-              <a:t/>
-            </a:r>
             <a:endParaRPr lang="en-US" dirty="0"/>
           </a:p>
         </p:txBody>
@@ -1393,10 +1134,6 @@
           <a:bodyPr/>
           <a:lstStyle/>
           <a:p>
-            <a:r>
-              <a:rPr lang="en-US" dirty="0"/>
-              <a:t/>
-            </a:r>
             <a:endParaRPr lang="en-US" dirty="0"/>
           </a:p>
         </p:txBody>
@@ -1481,10 +1218,6 @@
           <a:bodyPr/>
           <a:lstStyle/>
           <a:p>
-            <a:r>
-              <a:rPr lang="en-US" dirty="0"/>
-              <a:t/>
-            </a:r>
             <a:endParaRPr lang="en-US" dirty="0"/>
           </a:p>
         </p:txBody>
@@ -1569,10 +1302,6 @@
           <a:bodyPr/>
           <a:lstStyle/>
           <a:p>
-            <a:r>
-              <a:rPr lang="en-US" dirty="0"/>
-              <a:t/>
-            </a:r>
             <a:endParaRPr lang="en-US" dirty="0"/>
           </a:p>
         </p:txBody>
@@ -1657,10 +1386,6 @@
           <a:bodyPr/>
           <a:lstStyle/>
           <a:p>
-            <a:r>
-              <a:rPr lang="en-US" dirty="0"/>
-              <a:t/>
-            </a:r>
             <a:endParaRPr lang="en-US" dirty="0"/>
           </a:p>
         </p:txBody>
@@ -1734,6 +1459,11 @@
 <file path=ppt/slideMasters/slideMaster1.xml><?xml version="1.0" encoding="utf-8"?>
 <p:sldMaster xmlns:a="http://schemas.openxmlformats.org/drawingml/2006/main" xmlns:r="http://schemas.openxmlformats.org/officeDocument/2006/relationships" xmlns:p="http://schemas.openxmlformats.org/presentationml/2006/main">
   <p:cSld>
+    <p:bg>
+      <p:bgRef idx="1001">
+        <a:schemeClr val="bg1"/>
+      </p:bgRef>
+    </p:bg>
     <p:spTree>
       <p:nvGrpSpPr>
         <p:cNvPr id="1" name=""/>
@@ -2016,6 +1746,7 @@
         <a:solidFill>
           <a:srgbClr val="0D1321"/>
         </a:solidFill>
+        <a:effectLst/>
       </p:bgPr>
     </p:bg>
     <p:spTree>
@@ -2051,6 +1782,13 @@
           </a:solidFill>
           <a:ln/>
         </p:spPr>
+        <p:txBody>
+          <a:bodyPr/>
+          <a:lstStyle/>
+          <a:p>
+            <a:endParaRPr lang="en-ID"/>
+          </a:p>
+        </p:txBody>
       </p:sp>
       <p:sp>
         <p:nvSpPr>
@@ -2073,7 +1811,7 @@
           <a:bodyPr wrap="square" lIns="0" tIns="0" rIns="0" bIns="0" rtlCol="0" anchor="ctr"/>
           <a:lstStyle/>
           <a:p>
-            <a:pPr indent="0" marL="0">
+            <a:pPr marL="0" indent="0">
               <a:buNone/>
             </a:pPr>
             <a:r>
@@ -2087,9 +1825,6 @@
               </a:rPr>
               <a:t>belajar</a:t>
             </a:r>
-            <a:pPr indent="0" marL="0">
-              <a:buNone/>
-            </a:pPr>
             <a:r>
               <a:rPr lang="en-US" sz="2200" b="1" dirty="0">
                 <a:solidFill>
@@ -2131,6 +1866,13 @@
             <a:prstDash val="solid"/>
           </a:ln>
         </p:spPr>
+        <p:txBody>
+          <a:bodyPr/>
+          <a:lstStyle/>
+          <a:p>
+            <a:endParaRPr lang="en-ID"/>
+          </a:p>
+        </p:txBody>
       </p:sp>
       <p:sp>
         <p:nvSpPr>
@@ -2153,7 +1895,7 @@
           <a:bodyPr wrap="square" lIns="0" tIns="0" rIns="0" bIns="0" rtlCol="0" anchor="ctr"/>
           <a:lstStyle/>
           <a:p>
-            <a:pPr algn="ctr" indent="0" marL="0">
+            <a:pPr marL="0" indent="0" algn="ctr">
               <a:buNone/>
             </a:pPr>
             <a:r>
@@ -2192,7 +1934,7 @@
           <a:bodyPr wrap="square" lIns="0" tIns="0" rIns="0" bIns="0" rtlCol="0" anchor="t"/>
           <a:lstStyle/>
           <a:p>
-            <a:pPr indent="0" marL="0">
+            <a:pPr marL="0" indent="0">
               <a:lnSpc>
                 <a:spcPts val="5000"/>
               </a:lnSpc>
@@ -2212,7 +1954,7 @@
             <a:endParaRPr lang="en-US" sz="4400" dirty="0"/>
           </a:p>
           <a:p>
-            <a:pPr indent="0" marL="0">
+            <a:pPr marL="0" indent="0">
               <a:lnSpc>
                 <a:spcPts val="5000"/>
               </a:lnSpc>
@@ -2254,7 +1996,7 @@
           <a:bodyPr wrap="square" lIns="0" tIns="0" rIns="0" bIns="0" rtlCol="0" anchor="t"/>
           <a:lstStyle/>
           <a:p>
-            <a:pPr indent="0" marL="0">
+            <a:pPr marL="0" indent="0">
               <a:lnSpc>
                 <a:spcPct val="130000"/>
               </a:lnSpc>
@@ -2291,6 +2033,7 @@
         <a:solidFill>
           <a:srgbClr val="FFFFFF"/>
         </a:solidFill>
+        <a:effectLst/>
       </p:bgPr>
     </p:bg>
     <p:spTree>
@@ -2326,6 +2069,13 @@
           </a:solidFill>
           <a:ln/>
         </p:spPr>
+        <p:txBody>
+          <a:bodyPr/>
+          <a:lstStyle/>
+          <a:p>
+            <a:endParaRPr lang="en-ID"/>
+          </a:p>
+        </p:txBody>
       </p:sp>
       <p:sp>
         <p:nvSpPr>
@@ -2346,6 +2096,13 @@
           </a:solidFill>
           <a:ln/>
         </p:spPr>
+        <p:txBody>
+          <a:bodyPr/>
+          <a:lstStyle/>
+          <a:p>
+            <a:endParaRPr lang="en-ID"/>
+          </a:p>
+        </p:txBody>
       </p:sp>
       <p:sp>
         <p:nvSpPr>
@@ -2368,7 +2125,7 @@
           <a:bodyPr wrap="square" lIns="0" tIns="0" rIns="0" bIns="0" rtlCol="0" anchor="ctr"/>
           <a:lstStyle/>
           <a:p>
-            <a:pPr indent="0" marL="0">
+            <a:pPr marL="0" indent="0">
               <a:buNone/>
             </a:pPr>
             <a:r>
@@ -2382,9 +2139,6 @@
               </a:rPr>
               <a:t>belajar</a:t>
             </a:r>
-            <a:pPr indent="0" marL="0">
-              <a:buNone/>
-            </a:pPr>
             <a:r>
               <a:rPr lang="en-US" sz="2000" b="1" dirty="0">
                 <a:solidFill>
@@ -2421,7 +2175,7 @@
           <a:bodyPr wrap="square" lIns="0" tIns="0" rIns="0" bIns="0" rtlCol="0" anchor="ctr"/>
           <a:lstStyle/>
           <a:p>
-            <a:pPr algn="r" indent="0" marL="0">
+            <a:pPr marL="0" indent="0" algn="r">
               <a:buNone/>
             </a:pPr>
             <a:r>
@@ -2460,7 +2214,7 @@
           <a:bodyPr wrap="square" lIns="0" tIns="0" rIns="0" bIns="0" rtlCol="0" anchor="ctr"/>
           <a:lstStyle/>
           <a:p>
-            <a:pPr indent="0" marL="0">
+            <a:pPr marL="0" indent="0">
               <a:buNone/>
             </a:pPr>
             <a:r>
@@ -2499,11 +2253,11 @@
           <a:bodyPr wrap="square" lIns="0" tIns="0" rIns="0" bIns="0" rtlCol="0" anchor="ctr"/>
           <a:lstStyle/>
           <a:p>
-            <a:pPr indent="0" marL="0">
-              <a:buNone/>
-            </a:pPr>
-            <a:r>
-              <a:rPr lang="en-US" sz="1250" b="1" spc="40" kern="0" dirty="0">
+            <a:pPr marL="0" indent="0">
+              <a:buNone/>
+            </a:pPr>
+            <a:r>
+              <a:rPr lang="en-US" sz="1250" b="1" kern="0" spc="40" dirty="0">
                 <a:solidFill>
                   <a:srgbClr val="4B36C7"/>
                 </a:solidFill>
@@ -2538,7 +2292,7 @@
           <a:bodyPr wrap="square" lIns="0" tIns="0" rIns="0" bIns="0" rtlCol="0" anchor="t"/>
           <a:lstStyle/>
           <a:p>
-            <a:pPr indent="0" marL="0">
+            <a:pPr marL="0" indent="0">
               <a:lnSpc>
                 <a:spcPct val="125000"/>
               </a:lnSpc>
@@ -2580,11 +2334,11 @@
           <a:bodyPr wrap="square" lIns="0" tIns="0" rIns="0" bIns="0" rtlCol="0" anchor="ctr"/>
           <a:lstStyle/>
           <a:p>
-            <a:pPr indent="0" marL="0">
-              <a:buNone/>
-            </a:pPr>
-            <a:r>
-              <a:rPr lang="en-US" sz="1250" b="1" spc="40" kern="0" dirty="0">
+            <a:pPr marL="0" indent="0">
+              <a:buNone/>
+            </a:pPr>
+            <a:r>
+              <a:rPr lang="en-US" sz="1250" b="1" kern="0" spc="40" dirty="0">
                 <a:solidFill>
                   <a:srgbClr val="4B36C7"/>
                 </a:solidFill>
@@ -2624,6 +2378,13 @@
             <a:prstDash val="solid"/>
           </a:ln>
         </p:spPr>
+        <p:txBody>
+          <a:bodyPr/>
+          <a:lstStyle/>
+          <a:p>
+            <a:endParaRPr lang="en-ID"/>
+          </a:p>
+        </p:txBody>
       </p:sp>
       <p:sp>
         <p:nvSpPr>
@@ -2646,11 +2407,11 @@
           <a:bodyPr wrap="square" lIns="0" tIns="0" rIns="0" bIns="0" rtlCol="0" anchor="ctr"/>
           <a:lstStyle/>
           <a:p>
-            <a:pPr indent="0" marL="0">
-              <a:buNone/>
-            </a:pPr>
-            <a:r>
-              <a:rPr lang="en-US" sz="950" b="1" spc="50" kern="0" dirty="0">
+            <a:pPr marL="0" indent="0">
+              <a:buNone/>
+            </a:pPr>
+            <a:r>
+              <a:rPr lang="en-US" sz="950" b="1" kern="0" spc="50" dirty="0">
                 <a:solidFill>
                   <a:srgbClr val="9AA2B4"/>
                 </a:solidFill>
@@ -2685,7 +2446,7 @@
           <a:bodyPr wrap="square" lIns="0" tIns="0" rIns="0" bIns="0" rtlCol="0" anchor="t"/>
           <a:lstStyle/>
           <a:p>
-            <a:pPr indent="0" marL="0">
+            <a:pPr marL="0" indent="0">
               <a:lnSpc>
                 <a:spcPct val="130000"/>
               </a:lnSpc>
@@ -2732,6 +2493,13 @@
             <a:prstDash val="solid"/>
           </a:ln>
         </p:spPr>
+        <p:txBody>
+          <a:bodyPr/>
+          <a:lstStyle/>
+          <a:p>
+            <a:endParaRPr lang="en-ID"/>
+          </a:p>
+        </p:txBody>
       </p:sp>
       <p:sp>
         <p:nvSpPr>
@@ -2754,11 +2522,11 @@
           <a:bodyPr wrap="square" lIns="0" tIns="0" rIns="0" bIns="0" rtlCol="0" anchor="ctr"/>
           <a:lstStyle/>
           <a:p>
-            <a:pPr indent="0" marL="0">
-              <a:buNone/>
-            </a:pPr>
-            <a:r>
-              <a:rPr lang="en-US" sz="1100" b="1" spc="40" kern="0" dirty="0">
+            <a:pPr marL="0" indent="0">
+              <a:buNone/>
+            </a:pPr>
+            <a:r>
+              <a:rPr lang="en-US" sz="1100" b="1" kern="0" spc="40" dirty="0">
                 <a:solidFill>
                   <a:srgbClr val="1A7A44"/>
                 </a:solidFill>
@@ -2793,7 +2561,7 @@
           <a:bodyPr wrap="square" lIns="0" tIns="0" rIns="0" bIns="0" rtlCol="0" anchor="t"/>
           <a:lstStyle/>
           <a:p>
-            <a:pPr indent="0" marL="0">
+            <a:pPr marL="0" indent="0">
               <a:lnSpc>
                 <a:spcPct val="125000"/>
               </a:lnSpc>
@@ -2830,6 +2598,7 @@
         <a:solidFill>
           <a:srgbClr val="FFFFFF"/>
         </a:solidFill>
+        <a:effectLst/>
       </p:bgPr>
     </p:bg>
     <p:spTree>
@@ -2865,6 +2634,13 @@
           </a:solidFill>
           <a:ln/>
         </p:spPr>
+        <p:txBody>
+          <a:bodyPr/>
+          <a:lstStyle/>
+          <a:p>
+            <a:endParaRPr lang="en-ID"/>
+          </a:p>
+        </p:txBody>
       </p:sp>
       <p:sp>
         <p:nvSpPr>
@@ -2885,6 +2661,13 @@
           </a:solidFill>
           <a:ln/>
         </p:spPr>
+        <p:txBody>
+          <a:bodyPr/>
+          <a:lstStyle/>
+          <a:p>
+            <a:endParaRPr lang="en-ID"/>
+          </a:p>
+        </p:txBody>
       </p:sp>
       <p:sp>
         <p:nvSpPr>
@@ -2907,7 +2690,7 @@
           <a:bodyPr wrap="square" lIns="0" tIns="0" rIns="0" bIns="0" rtlCol="0" anchor="ctr"/>
           <a:lstStyle/>
           <a:p>
-            <a:pPr indent="0" marL="0">
+            <a:pPr marL="0" indent="0">
               <a:buNone/>
             </a:pPr>
             <a:r>
@@ -2921,9 +2704,6 @@
               </a:rPr>
               <a:t>belajar</a:t>
             </a:r>
-            <a:pPr indent="0" marL="0">
-              <a:buNone/>
-            </a:pPr>
             <a:r>
               <a:rPr lang="en-US" sz="2000" b="1" dirty="0">
                 <a:solidFill>
@@ -2960,7 +2740,7 @@
           <a:bodyPr wrap="square" lIns="0" tIns="0" rIns="0" bIns="0" rtlCol="0" anchor="ctr"/>
           <a:lstStyle/>
           <a:p>
-            <a:pPr algn="r" indent="0" marL="0">
+            <a:pPr marL="0" indent="0" algn="r">
               <a:buNone/>
             </a:pPr>
             <a:r>
@@ -2999,7 +2779,7 @@
           <a:bodyPr wrap="square" lIns="0" tIns="0" rIns="0" bIns="0" rtlCol="0" anchor="ctr"/>
           <a:lstStyle/>
           <a:p>
-            <a:pPr indent="0" marL="0">
+            <a:pPr marL="0" indent="0">
               <a:buNone/>
             </a:pPr>
             <a:r>
@@ -3038,11 +2818,11 @@
           <a:bodyPr wrap="square" lIns="0" tIns="0" rIns="0" bIns="0" rtlCol="0" anchor="ctr"/>
           <a:lstStyle/>
           <a:p>
-            <a:pPr indent="0" marL="0">
-              <a:buNone/>
-            </a:pPr>
-            <a:r>
-              <a:rPr lang="en-US" sz="1250" b="1" spc="40" kern="0" dirty="0">
+            <a:pPr marL="0" indent="0">
+              <a:buNone/>
+            </a:pPr>
+            <a:r>
+              <a:rPr lang="en-US" sz="1250" b="1" kern="0" spc="40" dirty="0">
                 <a:solidFill>
                   <a:srgbClr val="4B36C7"/>
                 </a:solidFill>
@@ -3077,7 +2857,7 @@
           <a:bodyPr wrap="square" lIns="0" tIns="0" rIns="0" bIns="0" rtlCol="0" anchor="t"/>
           <a:lstStyle/>
           <a:p>
-            <a:pPr indent="0" marL="0">
+            <a:pPr marL="0" indent="0">
               <a:lnSpc>
                 <a:spcPct val="125000"/>
               </a:lnSpc>
@@ -3119,11 +2899,11 @@
           <a:bodyPr wrap="square" lIns="0" tIns="0" rIns="0" bIns="0" rtlCol="0" anchor="ctr"/>
           <a:lstStyle/>
           <a:p>
-            <a:pPr indent="0" marL="0">
-              <a:buNone/>
-            </a:pPr>
-            <a:r>
-              <a:rPr lang="en-US" sz="1250" b="1" spc="40" kern="0" dirty="0">
+            <a:pPr marL="0" indent="0">
+              <a:buNone/>
+            </a:pPr>
+            <a:r>
+              <a:rPr lang="en-US" sz="1250" b="1" kern="0" spc="40" dirty="0">
                 <a:solidFill>
                   <a:srgbClr val="4B36C7"/>
                 </a:solidFill>
@@ -3163,6 +2943,13 @@
             <a:prstDash val="solid"/>
           </a:ln>
         </p:spPr>
+        <p:txBody>
+          <a:bodyPr/>
+          <a:lstStyle/>
+          <a:p>
+            <a:endParaRPr lang="en-ID"/>
+          </a:p>
+        </p:txBody>
       </p:sp>
       <p:sp>
         <p:nvSpPr>
@@ -3185,11 +2972,11 @@
           <a:bodyPr wrap="square" lIns="0" tIns="0" rIns="0" bIns="0" rtlCol="0" anchor="ctr"/>
           <a:lstStyle/>
           <a:p>
-            <a:pPr indent="0" marL="0">
-              <a:buNone/>
-            </a:pPr>
-            <a:r>
-              <a:rPr lang="en-US" sz="950" b="1" spc="50" kern="0" dirty="0">
+            <a:pPr marL="0" indent="0">
+              <a:buNone/>
+            </a:pPr>
+            <a:r>
+              <a:rPr lang="en-US" sz="950" b="1" kern="0" spc="50" dirty="0">
                 <a:solidFill>
                   <a:srgbClr val="9AA2B4"/>
                 </a:solidFill>
@@ -3224,7 +3011,7 @@
           <a:bodyPr wrap="square" lIns="0" tIns="0" rIns="0" bIns="0" rtlCol="0" anchor="t"/>
           <a:lstStyle/>
           <a:p>
-            <a:pPr indent="0" marL="0">
+            <a:pPr marL="0" indent="0">
               <a:lnSpc>
                 <a:spcPct val="130000"/>
               </a:lnSpc>
@@ -3271,6 +3058,13 @@
             <a:prstDash val="solid"/>
           </a:ln>
         </p:spPr>
+        <p:txBody>
+          <a:bodyPr/>
+          <a:lstStyle/>
+          <a:p>
+            <a:endParaRPr lang="en-ID"/>
+          </a:p>
+        </p:txBody>
       </p:sp>
       <p:sp>
         <p:nvSpPr>
@@ -3293,11 +3087,11 @@
           <a:bodyPr wrap="square" lIns="0" tIns="0" rIns="0" bIns="0" rtlCol="0" anchor="ctr"/>
           <a:lstStyle/>
           <a:p>
-            <a:pPr indent="0" marL="0">
-              <a:buNone/>
-            </a:pPr>
-            <a:r>
-              <a:rPr lang="en-US" sz="1100" b="1" spc="40" kern="0" dirty="0">
+            <a:pPr marL="0" indent="0">
+              <a:buNone/>
+            </a:pPr>
+            <a:r>
+              <a:rPr lang="en-US" sz="1100" b="1" kern="0" spc="40" dirty="0">
                 <a:solidFill>
                   <a:srgbClr val="1A7A44"/>
                 </a:solidFill>
@@ -3332,7 +3126,7 @@
           <a:bodyPr wrap="square" lIns="0" tIns="0" rIns="0" bIns="0" rtlCol="0" anchor="t"/>
           <a:lstStyle/>
           <a:p>
-            <a:pPr indent="0" marL="0">
+            <a:pPr marL="0" indent="0">
               <a:lnSpc>
                 <a:spcPct val="125000"/>
               </a:lnSpc>
@@ -3369,6 +3163,7 @@
         <a:solidFill>
           <a:srgbClr val="FFFFFF"/>
         </a:solidFill>
+        <a:effectLst/>
       </p:bgPr>
     </p:bg>
     <p:spTree>
@@ -3404,6 +3199,13 @@
           </a:solidFill>
           <a:ln/>
         </p:spPr>
+        <p:txBody>
+          <a:bodyPr/>
+          <a:lstStyle/>
+          <a:p>
+            <a:endParaRPr lang="en-ID"/>
+          </a:p>
+        </p:txBody>
       </p:sp>
       <p:sp>
         <p:nvSpPr>
@@ -3424,6 +3226,13 @@
           </a:solidFill>
           <a:ln/>
         </p:spPr>
+        <p:txBody>
+          <a:bodyPr/>
+          <a:lstStyle/>
+          <a:p>
+            <a:endParaRPr lang="en-ID"/>
+          </a:p>
+        </p:txBody>
       </p:sp>
       <p:sp>
         <p:nvSpPr>
@@ -3446,7 +3255,7 @@
           <a:bodyPr wrap="square" lIns="0" tIns="0" rIns="0" bIns="0" rtlCol="0" anchor="ctr"/>
           <a:lstStyle/>
           <a:p>
-            <a:pPr indent="0" marL="0">
+            <a:pPr marL="0" indent="0">
               <a:buNone/>
             </a:pPr>
             <a:r>
@@ -3460,9 +3269,6 @@
               </a:rPr>
               <a:t>belajar</a:t>
             </a:r>
-            <a:pPr indent="0" marL="0">
-              <a:buNone/>
-            </a:pPr>
             <a:r>
               <a:rPr lang="en-US" sz="2000" b="1" dirty="0">
                 <a:solidFill>
@@ -3499,7 +3305,7 @@
           <a:bodyPr wrap="square" lIns="0" tIns="0" rIns="0" bIns="0" rtlCol="0" anchor="ctr"/>
           <a:lstStyle/>
           <a:p>
-            <a:pPr algn="r" indent="0" marL="0">
+            <a:pPr marL="0" indent="0" algn="r">
               <a:buNone/>
             </a:pPr>
             <a:r>
@@ -3538,7 +3344,7 @@
           <a:bodyPr wrap="square" lIns="0" tIns="0" rIns="0" bIns="0" rtlCol="0" anchor="ctr"/>
           <a:lstStyle/>
           <a:p>
-            <a:pPr indent="0" marL="0">
+            <a:pPr marL="0" indent="0">
               <a:buNone/>
             </a:pPr>
             <a:r>
@@ -3577,11 +3383,11 @@
           <a:bodyPr wrap="square" lIns="0" tIns="0" rIns="0" bIns="0" rtlCol="0" anchor="ctr"/>
           <a:lstStyle/>
           <a:p>
-            <a:pPr indent="0" marL="0">
-              <a:buNone/>
-            </a:pPr>
-            <a:r>
-              <a:rPr lang="en-US" sz="1250" b="1" spc="40" kern="0" dirty="0">
+            <a:pPr marL="0" indent="0">
+              <a:buNone/>
+            </a:pPr>
+            <a:r>
+              <a:rPr lang="en-US" sz="1250" b="1" kern="0" spc="40" dirty="0">
                 <a:solidFill>
                   <a:srgbClr val="4B36C7"/>
                 </a:solidFill>
@@ -3616,7 +3422,7 @@
           <a:bodyPr wrap="square" lIns="0" tIns="0" rIns="0" bIns="0" rtlCol="0" anchor="t"/>
           <a:lstStyle/>
           <a:p>
-            <a:pPr indent="0" marL="0">
+            <a:pPr marL="0" indent="0">
               <a:lnSpc>
                 <a:spcPct val="125000"/>
               </a:lnSpc>
@@ -3658,11 +3464,11 @@
           <a:bodyPr wrap="square" lIns="0" tIns="0" rIns="0" bIns="0" rtlCol="0" anchor="ctr"/>
           <a:lstStyle/>
           <a:p>
-            <a:pPr indent="0" marL="0">
-              <a:buNone/>
-            </a:pPr>
-            <a:r>
-              <a:rPr lang="en-US" sz="1250" b="1" spc="40" kern="0" dirty="0">
+            <a:pPr marL="0" indent="0">
+              <a:buNone/>
+            </a:pPr>
+            <a:r>
+              <a:rPr lang="en-US" sz="1250" b="1" kern="0" spc="40" dirty="0">
                 <a:solidFill>
                   <a:srgbClr val="4B36C7"/>
                 </a:solidFill>
@@ -3702,6 +3508,13 @@
             <a:prstDash val="solid"/>
           </a:ln>
         </p:spPr>
+        <p:txBody>
+          <a:bodyPr/>
+          <a:lstStyle/>
+          <a:p>
+            <a:endParaRPr lang="en-ID"/>
+          </a:p>
+        </p:txBody>
       </p:sp>
       <p:sp>
         <p:nvSpPr>
@@ -3724,11 +3537,11 @@
           <a:bodyPr wrap="square" lIns="0" tIns="0" rIns="0" bIns="0" rtlCol="0" anchor="ctr"/>
           <a:lstStyle/>
           <a:p>
-            <a:pPr indent="0" marL="0">
-              <a:buNone/>
-            </a:pPr>
-            <a:r>
-              <a:rPr lang="en-US" sz="950" b="1" spc="50" kern="0" dirty="0">
+            <a:pPr marL="0" indent="0">
+              <a:buNone/>
+            </a:pPr>
+            <a:r>
+              <a:rPr lang="en-US" sz="950" b="1" kern="0" spc="50" dirty="0">
                 <a:solidFill>
                   <a:srgbClr val="9AA2B4"/>
                 </a:solidFill>
@@ -3763,7 +3576,7 @@
           <a:bodyPr wrap="square" lIns="0" tIns="0" rIns="0" bIns="0" rtlCol="0" anchor="t"/>
           <a:lstStyle/>
           <a:p>
-            <a:pPr indent="0" marL="0">
+            <a:pPr marL="0" indent="0">
               <a:lnSpc>
                 <a:spcPct val="130000"/>
               </a:lnSpc>
@@ -3810,6 +3623,13 @@
             <a:prstDash val="solid"/>
           </a:ln>
         </p:spPr>
+        <p:txBody>
+          <a:bodyPr/>
+          <a:lstStyle/>
+          <a:p>
+            <a:endParaRPr lang="en-ID"/>
+          </a:p>
+        </p:txBody>
       </p:sp>
       <p:sp>
         <p:nvSpPr>
@@ -3832,11 +3652,11 @@
           <a:bodyPr wrap="square" lIns="0" tIns="0" rIns="0" bIns="0" rtlCol="0" anchor="ctr"/>
           <a:lstStyle/>
           <a:p>
-            <a:pPr indent="0" marL="0">
-              <a:buNone/>
-            </a:pPr>
-            <a:r>
-              <a:rPr lang="en-US" sz="1100" b="1" spc="40" kern="0" dirty="0">
+            <a:pPr marL="0" indent="0">
+              <a:buNone/>
+            </a:pPr>
+            <a:r>
+              <a:rPr lang="en-US" sz="1100" b="1" kern="0" spc="40" dirty="0">
                 <a:solidFill>
                   <a:srgbClr val="1A7A44"/>
                 </a:solidFill>
@@ -3871,7 +3691,7 @@
           <a:bodyPr wrap="square" lIns="0" tIns="0" rIns="0" bIns="0" rtlCol="0" anchor="t"/>
           <a:lstStyle/>
           <a:p>
-            <a:pPr indent="0" marL="0">
+            <a:pPr marL="0" indent="0">
               <a:lnSpc>
                 <a:spcPct val="125000"/>
               </a:lnSpc>
@@ -3908,6 +3728,7 @@
         <a:solidFill>
           <a:srgbClr val="FFFFFF"/>
         </a:solidFill>
+        <a:effectLst/>
       </p:bgPr>
     </p:bg>
     <p:spTree>
@@ -3943,6 +3764,13 @@
           </a:solidFill>
           <a:ln/>
         </p:spPr>
+        <p:txBody>
+          <a:bodyPr/>
+          <a:lstStyle/>
+          <a:p>
+            <a:endParaRPr lang="en-ID"/>
+          </a:p>
+        </p:txBody>
       </p:sp>
       <p:sp>
         <p:nvSpPr>
@@ -3963,6 +3791,13 @@
           </a:solidFill>
           <a:ln/>
         </p:spPr>
+        <p:txBody>
+          <a:bodyPr/>
+          <a:lstStyle/>
+          <a:p>
+            <a:endParaRPr lang="en-ID"/>
+          </a:p>
+        </p:txBody>
       </p:sp>
       <p:sp>
         <p:nvSpPr>
@@ -3985,7 +3820,7 @@
           <a:bodyPr wrap="square" lIns="0" tIns="0" rIns="0" bIns="0" rtlCol="0" anchor="ctr"/>
           <a:lstStyle/>
           <a:p>
-            <a:pPr indent="0" marL="0">
+            <a:pPr marL="0" indent="0">
               <a:buNone/>
             </a:pPr>
             <a:r>
@@ -3999,9 +3834,6 @@
               </a:rPr>
               <a:t>belajar</a:t>
             </a:r>
-            <a:pPr indent="0" marL="0">
-              <a:buNone/>
-            </a:pPr>
             <a:r>
               <a:rPr lang="en-US" sz="2000" b="1" dirty="0">
                 <a:solidFill>
@@ -4038,7 +3870,7 @@
           <a:bodyPr wrap="square" lIns="0" tIns="0" rIns="0" bIns="0" rtlCol="0" anchor="ctr"/>
           <a:lstStyle/>
           <a:p>
-            <a:pPr algn="r" indent="0" marL="0">
+            <a:pPr marL="0" indent="0" algn="r">
               <a:buNone/>
             </a:pPr>
             <a:r>
@@ -4077,7 +3909,7 @@
           <a:bodyPr wrap="square" lIns="0" tIns="0" rIns="0" bIns="0" rtlCol="0" anchor="ctr"/>
           <a:lstStyle/>
           <a:p>
-            <a:pPr indent="0" marL="0">
+            <a:pPr marL="0" indent="0">
               <a:buNone/>
             </a:pPr>
             <a:r>
@@ -4116,11 +3948,11 @@
           <a:bodyPr wrap="square" lIns="0" tIns="0" rIns="0" bIns="0" rtlCol="0" anchor="ctr"/>
           <a:lstStyle/>
           <a:p>
-            <a:pPr indent="0" marL="0">
-              <a:buNone/>
-            </a:pPr>
-            <a:r>
-              <a:rPr lang="en-US" sz="1250" b="1" spc="40" kern="0" dirty="0">
+            <a:pPr marL="0" indent="0">
+              <a:buNone/>
+            </a:pPr>
+            <a:r>
+              <a:rPr lang="en-US" sz="1250" b="1" kern="0" spc="40" dirty="0">
                 <a:solidFill>
                   <a:srgbClr val="4B36C7"/>
                 </a:solidFill>
@@ -4155,7 +3987,7 @@
           <a:bodyPr wrap="square" lIns="0" tIns="0" rIns="0" bIns="0" rtlCol="0" anchor="t"/>
           <a:lstStyle/>
           <a:p>
-            <a:pPr indent="0" marL="0">
+            <a:pPr marL="0" indent="0">
               <a:lnSpc>
                 <a:spcPct val="125000"/>
               </a:lnSpc>
@@ -4197,11 +4029,11 @@
           <a:bodyPr wrap="square" lIns="0" tIns="0" rIns="0" bIns="0" rtlCol="0" anchor="ctr"/>
           <a:lstStyle/>
           <a:p>
-            <a:pPr indent="0" marL="0">
-              <a:buNone/>
-            </a:pPr>
-            <a:r>
-              <a:rPr lang="en-US" sz="1250" b="1" spc="40" kern="0" dirty="0">
+            <a:pPr marL="0" indent="0">
+              <a:buNone/>
+            </a:pPr>
+            <a:r>
+              <a:rPr lang="en-US" sz="1250" b="1" kern="0" spc="40" dirty="0">
                 <a:solidFill>
                   <a:srgbClr val="4B36C7"/>
                 </a:solidFill>
@@ -4241,6 +4073,13 @@
             <a:prstDash val="solid"/>
           </a:ln>
         </p:spPr>
+        <p:txBody>
+          <a:bodyPr/>
+          <a:lstStyle/>
+          <a:p>
+            <a:endParaRPr lang="en-ID"/>
+          </a:p>
+        </p:txBody>
       </p:sp>
       <p:sp>
         <p:nvSpPr>
@@ -4263,11 +4102,11 @@
           <a:bodyPr wrap="square" lIns="0" tIns="0" rIns="0" bIns="0" rtlCol="0" anchor="ctr"/>
           <a:lstStyle/>
           <a:p>
-            <a:pPr indent="0" marL="0">
-              <a:buNone/>
-            </a:pPr>
-            <a:r>
-              <a:rPr lang="en-US" sz="950" b="1" spc="50" kern="0" dirty="0">
+            <a:pPr marL="0" indent="0">
+              <a:buNone/>
+            </a:pPr>
+            <a:r>
+              <a:rPr lang="en-US" sz="950" b="1" kern="0" spc="50" dirty="0">
                 <a:solidFill>
                   <a:srgbClr val="9AA2B4"/>
                 </a:solidFill>
@@ -4302,7 +4141,7 @@
           <a:bodyPr wrap="square" lIns="0" tIns="0" rIns="0" bIns="0" rtlCol="0" anchor="t"/>
           <a:lstStyle/>
           <a:p>
-            <a:pPr indent="0" marL="0">
+            <a:pPr marL="0" indent="0">
               <a:lnSpc>
                 <a:spcPct val="130000"/>
               </a:lnSpc>
@@ -4349,6 +4188,13 @@
             <a:prstDash val="solid"/>
           </a:ln>
         </p:spPr>
+        <p:txBody>
+          <a:bodyPr/>
+          <a:lstStyle/>
+          <a:p>
+            <a:endParaRPr lang="en-ID"/>
+          </a:p>
+        </p:txBody>
       </p:sp>
       <p:sp>
         <p:nvSpPr>
@@ -4371,11 +4217,11 @@
           <a:bodyPr wrap="square" lIns="0" tIns="0" rIns="0" bIns="0" rtlCol="0" anchor="ctr"/>
           <a:lstStyle/>
           <a:p>
-            <a:pPr indent="0" marL="0">
-              <a:buNone/>
-            </a:pPr>
-            <a:r>
-              <a:rPr lang="en-US" sz="1100" b="1" spc="40" kern="0" dirty="0">
+            <a:pPr marL="0" indent="0">
+              <a:buNone/>
+            </a:pPr>
+            <a:r>
+              <a:rPr lang="en-US" sz="1100" b="1" kern="0" spc="40" dirty="0">
                 <a:solidFill>
                   <a:srgbClr val="1A7A44"/>
                 </a:solidFill>
@@ -4410,7 +4256,7 @@
           <a:bodyPr wrap="square" lIns="0" tIns="0" rIns="0" bIns="0" rtlCol="0" anchor="t"/>
           <a:lstStyle/>
           <a:p>
-            <a:pPr indent="0" marL="0">
+            <a:pPr marL="0" indent="0">
               <a:lnSpc>
                 <a:spcPct val="125000"/>
               </a:lnSpc>
@@ -4447,6 +4293,7 @@
         <a:solidFill>
           <a:srgbClr val="FFFFFF"/>
         </a:solidFill>
+        <a:effectLst/>
       </p:bgPr>
     </p:bg>
     <p:spTree>
@@ -4482,6 +4329,13 @@
           </a:solidFill>
           <a:ln/>
         </p:spPr>
+        <p:txBody>
+          <a:bodyPr/>
+          <a:lstStyle/>
+          <a:p>
+            <a:endParaRPr lang="en-ID"/>
+          </a:p>
+        </p:txBody>
       </p:sp>
       <p:sp>
         <p:nvSpPr>
@@ -4502,6 +4356,13 @@
           </a:solidFill>
           <a:ln/>
         </p:spPr>
+        <p:txBody>
+          <a:bodyPr/>
+          <a:lstStyle/>
+          <a:p>
+            <a:endParaRPr lang="en-ID"/>
+          </a:p>
+        </p:txBody>
       </p:sp>
       <p:sp>
         <p:nvSpPr>
@@ -4524,7 +4385,7 @@
           <a:bodyPr wrap="square" lIns="0" tIns="0" rIns="0" bIns="0" rtlCol="0" anchor="ctr"/>
           <a:lstStyle/>
           <a:p>
-            <a:pPr indent="0" marL="0">
+            <a:pPr marL="0" indent="0">
               <a:buNone/>
             </a:pPr>
             <a:r>
@@ -4538,9 +4399,6 @@
               </a:rPr>
               <a:t>belajar</a:t>
             </a:r>
-            <a:pPr indent="0" marL="0">
-              <a:buNone/>
-            </a:pPr>
             <a:r>
               <a:rPr lang="en-US" sz="2000" b="1" dirty="0">
                 <a:solidFill>
@@ -4577,7 +4435,7 @@
           <a:bodyPr wrap="square" lIns="0" tIns="0" rIns="0" bIns="0" rtlCol="0" anchor="ctr"/>
           <a:lstStyle/>
           <a:p>
-            <a:pPr algn="r" indent="0" marL="0">
+            <a:pPr marL="0" indent="0" algn="r">
               <a:buNone/>
             </a:pPr>
             <a:r>
@@ -4616,7 +4474,7 @@
           <a:bodyPr wrap="square" lIns="0" tIns="0" rIns="0" bIns="0" rtlCol="0" anchor="ctr"/>
           <a:lstStyle/>
           <a:p>
-            <a:pPr indent="0" marL="0">
+            <a:pPr marL="0" indent="0">
               <a:buNone/>
             </a:pPr>
             <a:r>
@@ -4655,11 +4513,11 @@
           <a:bodyPr wrap="square" lIns="0" tIns="0" rIns="0" bIns="0" rtlCol="0" anchor="ctr"/>
           <a:lstStyle/>
           <a:p>
-            <a:pPr indent="0" marL="0">
-              <a:buNone/>
-            </a:pPr>
-            <a:r>
-              <a:rPr lang="en-US" sz="1250" b="1" spc="40" kern="0" dirty="0">
+            <a:pPr marL="0" indent="0">
+              <a:buNone/>
+            </a:pPr>
+            <a:r>
+              <a:rPr lang="en-US" sz="1250" b="1" kern="0" spc="40" dirty="0">
                 <a:solidFill>
                   <a:srgbClr val="4B36C7"/>
                 </a:solidFill>
@@ -4694,7 +4552,7 @@
           <a:bodyPr wrap="square" lIns="0" tIns="0" rIns="0" bIns="0" rtlCol="0" anchor="t"/>
           <a:lstStyle/>
           <a:p>
-            <a:pPr indent="0" marL="0">
+            <a:pPr marL="0" indent="0">
               <a:lnSpc>
                 <a:spcPct val="125000"/>
               </a:lnSpc>
@@ -4741,6 +4599,13 @@
             <a:prstDash val="solid"/>
           </a:ln>
         </p:spPr>
+        <p:txBody>
+          <a:bodyPr/>
+          <a:lstStyle/>
+          <a:p>
+            <a:endParaRPr lang="en-ID"/>
+          </a:p>
+        </p:txBody>
       </p:sp>
       <p:sp>
         <p:nvSpPr>
@@ -4763,11 +4628,11 @@
           <a:bodyPr wrap="square" lIns="0" tIns="0" rIns="0" bIns="0" rtlCol="0" anchor="ctr"/>
           <a:lstStyle/>
           <a:p>
-            <a:pPr indent="0" marL="0">
-              <a:buNone/>
-            </a:pPr>
-            <a:r>
-              <a:rPr lang="en-US" sz="1100" b="1" spc="40" kern="0" dirty="0">
+            <a:pPr marL="0" indent="0">
+              <a:buNone/>
+            </a:pPr>
+            <a:r>
+              <a:rPr lang="en-US" sz="1100" b="1" kern="0" spc="40" dirty="0">
                 <a:solidFill>
                   <a:srgbClr val="1A7A44"/>
                 </a:solidFill>
@@ -4802,7 +4667,7 @@
           <a:bodyPr wrap="square" lIns="0" tIns="0" rIns="0" bIns="0" rtlCol="0" anchor="t"/>
           <a:lstStyle/>
           <a:p>
-            <a:pPr indent="0" marL="0">
+            <a:pPr marL="0" indent="0">
               <a:lnSpc>
                 <a:spcPct val="125000"/>
               </a:lnSpc>
@@ -4849,6 +4714,13 @@
             <a:prstDash val="solid"/>
           </a:ln>
         </p:spPr>
+        <p:txBody>
+          <a:bodyPr/>
+          <a:lstStyle/>
+          <a:p>
+            <a:endParaRPr lang="en-ID"/>
+          </a:p>
+        </p:txBody>
       </p:sp>
       <p:sp>
         <p:nvSpPr>
@@ -4871,11 +4743,11 @@
           <a:bodyPr wrap="square" lIns="0" tIns="0" rIns="0" bIns="0" rtlCol="0" anchor="ctr"/>
           <a:lstStyle/>
           <a:p>
-            <a:pPr indent="0" marL="0">
-              <a:buNone/>
-            </a:pPr>
-            <a:r>
-              <a:rPr lang="en-US" sz="1100" b="1" spc="40" kern="0" dirty="0">
+            <a:pPr marL="0" indent="0">
+              <a:buNone/>
+            </a:pPr>
+            <a:r>
+              <a:rPr lang="en-US" sz="1100" b="1" kern="0" spc="40" dirty="0">
                 <a:solidFill>
                   <a:srgbClr val="4B36C7"/>
                 </a:solidFill>
@@ -4910,7 +4782,7 @@
           <a:bodyPr wrap="square" lIns="0" tIns="0" rIns="0" bIns="0" rtlCol="0" anchor="t"/>
           <a:lstStyle/>
           <a:p>
-            <a:pPr indent="0" marL="0">
+            <a:pPr marL="0" indent="0">
               <a:lnSpc>
                 <a:spcPct val="125000"/>
               </a:lnSpc>
@@ -4947,6 +4819,7 @@
         <a:solidFill>
           <a:srgbClr val="FFFFFF"/>
         </a:solidFill>
+        <a:effectLst/>
       </p:bgPr>
     </p:bg>
     <p:spTree>
@@ -4982,6 +4855,13 @@
           </a:solidFill>
           <a:ln/>
         </p:spPr>
+        <p:txBody>
+          <a:bodyPr/>
+          <a:lstStyle/>
+          <a:p>
+            <a:endParaRPr lang="en-ID"/>
+          </a:p>
+        </p:txBody>
       </p:sp>
       <p:sp>
         <p:nvSpPr>
@@ -5002,6 +4882,13 @@
           </a:solidFill>
           <a:ln/>
         </p:spPr>
+        <p:txBody>
+          <a:bodyPr/>
+          <a:lstStyle/>
+          <a:p>
+            <a:endParaRPr lang="en-ID"/>
+          </a:p>
+        </p:txBody>
       </p:sp>
       <p:sp>
         <p:nvSpPr>
@@ -5024,7 +4911,7 @@
           <a:bodyPr wrap="square" lIns="0" tIns="0" rIns="0" bIns="0" rtlCol="0" anchor="ctr"/>
           <a:lstStyle/>
           <a:p>
-            <a:pPr indent="0" marL="0">
+            <a:pPr marL="0" indent="0">
               <a:buNone/>
             </a:pPr>
             <a:r>
@@ -5038,9 +4925,6 @@
               </a:rPr>
               <a:t>belajar</a:t>
             </a:r>
-            <a:pPr indent="0" marL="0">
-              <a:buNone/>
-            </a:pPr>
             <a:r>
               <a:rPr lang="en-US" sz="2000" b="1" dirty="0">
                 <a:solidFill>
@@ -5077,7 +4961,7 @@
           <a:bodyPr wrap="square" lIns="0" tIns="0" rIns="0" bIns="0" rtlCol="0" anchor="ctr"/>
           <a:lstStyle/>
           <a:p>
-            <a:pPr algn="r" indent="0" marL="0">
+            <a:pPr marL="0" indent="0" algn="r">
               <a:buNone/>
             </a:pPr>
             <a:r>
@@ -5116,7 +5000,7 @@
           <a:bodyPr wrap="square" lIns="0" tIns="0" rIns="0" bIns="0" rtlCol="0" anchor="ctr"/>
           <a:lstStyle/>
           <a:p>
-            <a:pPr indent="0" marL="0">
+            <a:pPr marL="0" indent="0">
               <a:buNone/>
             </a:pPr>
             <a:r>
@@ -5155,11 +5039,11 @@
           <a:bodyPr wrap="square" lIns="0" tIns="0" rIns="0" bIns="0" rtlCol="0" anchor="ctr"/>
           <a:lstStyle/>
           <a:p>
-            <a:pPr indent="0" marL="0">
-              <a:buNone/>
-            </a:pPr>
-            <a:r>
-              <a:rPr lang="en-US" sz="1250" b="1" spc="40" kern="0" dirty="0">
+            <a:pPr marL="0" indent="0">
+              <a:buNone/>
+            </a:pPr>
+            <a:r>
+              <a:rPr lang="en-US" sz="1250" b="1" kern="0" spc="40" dirty="0">
                 <a:solidFill>
                   <a:srgbClr val="4B36C7"/>
                 </a:solidFill>
@@ -5194,7 +5078,7 @@
           <a:bodyPr wrap="square" lIns="0" tIns="0" rIns="0" bIns="0" rtlCol="0" anchor="t"/>
           <a:lstStyle/>
           <a:p>
-            <a:pPr indent="0" marL="0">
+            <a:pPr marL="0" indent="0">
               <a:lnSpc>
                 <a:spcPct val="125000"/>
               </a:lnSpc>
@@ -5236,11 +5120,11 @@
           <a:bodyPr wrap="square" lIns="0" tIns="0" rIns="0" bIns="0" rtlCol="0" anchor="ctr"/>
           <a:lstStyle/>
           <a:p>
-            <a:pPr indent="0" marL="0">
-              <a:buNone/>
-            </a:pPr>
-            <a:r>
-              <a:rPr lang="en-US" sz="1250" b="1" spc="40" kern="0" dirty="0">
+            <a:pPr marL="0" indent="0">
+              <a:buNone/>
+            </a:pPr>
+            <a:r>
+              <a:rPr lang="en-US" sz="1250" b="1" kern="0" spc="40" dirty="0">
                 <a:solidFill>
                   <a:srgbClr val="4B36C7"/>
                 </a:solidFill>
@@ -5280,6 +5164,13 @@
             <a:prstDash val="solid"/>
           </a:ln>
         </p:spPr>
+        <p:txBody>
+          <a:bodyPr/>
+          <a:lstStyle/>
+          <a:p>
+            <a:endParaRPr lang="en-ID"/>
+          </a:p>
+        </p:txBody>
       </p:sp>
       <p:sp>
         <p:nvSpPr>
@@ -5302,11 +5193,11 @@
           <a:bodyPr wrap="square" lIns="0" tIns="0" rIns="0" bIns="0" rtlCol="0" anchor="ctr"/>
           <a:lstStyle/>
           <a:p>
-            <a:pPr indent="0" marL="0">
-              <a:buNone/>
-            </a:pPr>
-            <a:r>
-              <a:rPr lang="en-US" sz="950" b="1" spc="50" kern="0" dirty="0">
+            <a:pPr marL="0" indent="0">
+              <a:buNone/>
+            </a:pPr>
+            <a:r>
+              <a:rPr lang="en-US" sz="950" b="1" kern="0" spc="50" dirty="0">
                 <a:solidFill>
                   <a:srgbClr val="9AA2B4"/>
                 </a:solidFill>
@@ -5341,7 +5232,7 @@
           <a:bodyPr wrap="square" lIns="0" tIns="0" rIns="0" bIns="0" rtlCol="0" anchor="t"/>
           <a:lstStyle/>
           <a:p>
-            <a:pPr indent="0" marL="0">
+            <a:pPr marL="0" indent="0">
               <a:lnSpc>
                 <a:spcPct val="130000"/>
               </a:lnSpc>
@@ -5388,6 +5279,13 @@
             <a:prstDash val="solid"/>
           </a:ln>
         </p:spPr>
+        <p:txBody>
+          <a:bodyPr/>
+          <a:lstStyle/>
+          <a:p>
+            <a:endParaRPr lang="en-ID"/>
+          </a:p>
+        </p:txBody>
       </p:sp>
       <p:sp>
         <p:nvSpPr>
@@ -5410,11 +5308,11 @@
           <a:bodyPr wrap="square" lIns="0" tIns="0" rIns="0" bIns="0" rtlCol="0" anchor="ctr"/>
           <a:lstStyle/>
           <a:p>
-            <a:pPr indent="0" marL="0">
-              <a:buNone/>
-            </a:pPr>
-            <a:r>
-              <a:rPr lang="en-US" sz="1100" b="1" spc="40" kern="0" dirty="0">
+            <a:pPr marL="0" indent="0">
+              <a:buNone/>
+            </a:pPr>
+            <a:r>
+              <a:rPr lang="en-US" sz="1100" b="1" kern="0" spc="40" dirty="0">
                 <a:solidFill>
                   <a:srgbClr val="1A7A44"/>
                 </a:solidFill>
@@ -5449,7 +5347,7 @@
           <a:bodyPr wrap="square" lIns="0" tIns="0" rIns="0" bIns="0" rtlCol="0" anchor="t"/>
           <a:lstStyle/>
           <a:p>
-            <a:pPr indent="0" marL="0">
+            <a:pPr marL="0" indent="0">
               <a:lnSpc>
                 <a:spcPct val="125000"/>
               </a:lnSpc>
@@ -5486,6 +5384,7 @@
         <a:solidFill>
           <a:srgbClr val="FFFFFF"/>
         </a:solidFill>
+        <a:effectLst/>
       </p:bgPr>
     </p:bg>
     <p:spTree>
@@ -5521,6 +5420,13 @@
           </a:solidFill>
           <a:ln/>
         </p:spPr>
+        <p:txBody>
+          <a:bodyPr/>
+          <a:lstStyle/>
+          <a:p>
+            <a:endParaRPr lang="en-ID"/>
+          </a:p>
+        </p:txBody>
       </p:sp>
       <p:sp>
         <p:nvSpPr>
@@ -5541,6 +5447,13 @@
           </a:solidFill>
           <a:ln/>
         </p:spPr>
+        <p:txBody>
+          <a:bodyPr/>
+          <a:lstStyle/>
+          <a:p>
+            <a:endParaRPr lang="en-ID"/>
+          </a:p>
+        </p:txBody>
       </p:sp>
       <p:sp>
         <p:nvSpPr>
@@ -5563,7 +5476,7 @@
           <a:bodyPr wrap="square" lIns="0" tIns="0" rIns="0" bIns="0" rtlCol="0" anchor="ctr"/>
           <a:lstStyle/>
           <a:p>
-            <a:pPr indent="0" marL="0">
+            <a:pPr marL="0" indent="0">
               <a:buNone/>
             </a:pPr>
             <a:r>
@@ -5577,9 +5490,6 @@
               </a:rPr>
               <a:t>belajar</a:t>
             </a:r>
-            <a:pPr indent="0" marL="0">
-              <a:buNone/>
-            </a:pPr>
             <a:r>
               <a:rPr lang="en-US" sz="2000" b="1" dirty="0">
                 <a:solidFill>
@@ -5616,7 +5526,7 @@
           <a:bodyPr wrap="square" lIns="0" tIns="0" rIns="0" bIns="0" rtlCol="0" anchor="ctr"/>
           <a:lstStyle/>
           <a:p>
-            <a:pPr algn="r" indent="0" marL="0">
+            <a:pPr marL="0" indent="0" algn="r">
               <a:buNone/>
             </a:pPr>
             <a:r>
@@ -5655,7 +5565,7 @@
           <a:bodyPr wrap="square" lIns="0" tIns="0" rIns="0" bIns="0" rtlCol="0" anchor="ctr"/>
           <a:lstStyle/>
           <a:p>
-            <a:pPr indent="0" marL="0">
+            <a:pPr marL="0" indent="0">
               <a:buNone/>
             </a:pPr>
             <a:r>
@@ -5694,11 +5604,11 @@
           <a:bodyPr wrap="square" lIns="0" tIns="0" rIns="0" bIns="0" rtlCol="0" anchor="ctr"/>
           <a:lstStyle/>
           <a:p>
-            <a:pPr indent="0" marL="0">
-              <a:buNone/>
-            </a:pPr>
-            <a:r>
-              <a:rPr lang="en-US" sz="1250" b="1" spc="40" kern="0" dirty="0">
+            <a:pPr marL="0" indent="0">
+              <a:buNone/>
+            </a:pPr>
+            <a:r>
+              <a:rPr lang="en-US" sz="1250" b="1" kern="0" spc="40" dirty="0">
                 <a:solidFill>
                   <a:srgbClr val="4B36C7"/>
                 </a:solidFill>
@@ -5733,7 +5643,7 @@
           <a:bodyPr wrap="square" lIns="0" tIns="0" rIns="0" bIns="0" rtlCol="0" anchor="t"/>
           <a:lstStyle/>
           <a:p>
-            <a:pPr indent="0" marL="0">
+            <a:pPr marL="0" indent="0">
               <a:lnSpc>
                 <a:spcPct val="125000"/>
               </a:lnSpc>
@@ -5775,11 +5685,11 @@
           <a:bodyPr wrap="square" lIns="0" tIns="0" rIns="0" bIns="0" rtlCol="0" anchor="ctr"/>
           <a:lstStyle/>
           <a:p>
-            <a:pPr indent="0" marL="0">
-              <a:buNone/>
-            </a:pPr>
-            <a:r>
-              <a:rPr lang="en-US" sz="1250" b="1" spc="40" kern="0" dirty="0">
+            <a:pPr marL="0" indent="0">
+              <a:buNone/>
+            </a:pPr>
+            <a:r>
+              <a:rPr lang="en-US" sz="1250" b="1" kern="0" spc="40" dirty="0">
                 <a:solidFill>
                   <a:srgbClr val="4B36C7"/>
                 </a:solidFill>
@@ -5802,7 +5712,7 @@
         <p:spPr>
           <a:xfrm>
             <a:off x="548640" y="2811209"/>
-            <a:ext cx="11094415" cy="999744"/>
+            <a:ext cx="11094415" cy="1136904"/>
           </a:xfrm>
           <a:prstGeom prst="roundRect">
             <a:avLst>
@@ -5819,6 +5729,13 @@
             <a:prstDash val="solid"/>
           </a:ln>
         </p:spPr>
+        <p:txBody>
+          <a:bodyPr/>
+          <a:lstStyle/>
+          <a:p>
+            <a:endParaRPr lang="en-ID"/>
+          </a:p>
+        </p:txBody>
       </p:sp>
       <p:sp>
         <p:nvSpPr>
@@ -5841,11 +5758,11 @@
           <a:bodyPr wrap="square" lIns="0" tIns="0" rIns="0" bIns="0" rtlCol="0" anchor="ctr"/>
           <a:lstStyle/>
           <a:p>
-            <a:pPr indent="0" marL="0">
-              <a:buNone/>
-            </a:pPr>
-            <a:r>
-              <a:rPr lang="en-US" sz="950" b="1" spc="50" kern="0" dirty="0">
+            <a:pPr marL="0" indent="0">
+              <a:buNone/>
+            </a:pPr>
+            <a:r>
+              <a:rPr lang="en-US" sz="950" b="1" kern="0" spc="50" dirty="0">
                 <a:solidFill>
                   <a:srgbClr val="9AA2B4"/>
                 </a:solidFill>
@@ -5880,7 +5797,7 @@
           <a:bodyPr wrap="square" lIns="0" tIns="0" rIns="0" bIns="0" rtlCol="0" anchor="t"/>
           <a:lstStyle/>
           <a:p>
-            <a:pPr indent="0" marL="0">
+            <a:pPr marL="0" indent="0">
               <a:lnSpc>
                 <a:spcPct val="130000"/>
               </a:lnSpc>
@@ -5909,7 +5826,7 @@
         </p:nvSpPr>
         <p:spPr>
           <a:xfrm>
-            <a:off x="548640" y="4066984"/>
+            <a:off x="548640" y="4125224"/>
             <a:ext cx="11094415" cy="945515"/>
           </a:xfrm>
           <a:prstGeom prst="roundRect">
@@ -5927,6 +5844,13 @@
             <a:prstDash val="solid"/>
           </a:ln>
         </p:spPr>
+        <p:txBody>
+          <a:bodyPr/>
+          <a:lstStyle/>
+          <a:p>
+            <a:endParaRPr lang="en-ID"/>
+          </a:p>
+        </p:txBody>
       </p:sp>
       <p:sp>
         <p:nvSpPr>
@@ -5936,7 +5860,7 @@
         </p:nvSpPr>
         <p:spPr>
           <a:xfrm>
-            <a:off x="749808" y="4176712"/>
+            <a:off x="749808" y="4234952"/>
             <a:ext cx="10692079" cy="274320"/>
           </a:xfrm>
           <a:prstGeom prst="rect">
@@ -5949,11 +5873,11 @@
           <a:bodyPr wrap="square" lIns="0" tIns="0" rIns="0" bIns="0" rtlCol="0" anchor="ctr"/>
           <a:lstStyle/>
           <a:p>
-            <a:pPr indent="0" marL="0">
-              <a:buNone/>
-            </a:pPr>
-            <a:r>
-              <a:rPr lang="en-US" sz="1100" b="1" spc="40" kern="0" dirty="0">
+            <a:pPr marL="0" indent="0">
+              <a:buNone/>
+            </a:pPr>
+            <a:r>
+              <a:rPr lang="en-US" sz="1100" b="1" kern="0" spc="40" dirty="0">
                 <a:solidFill>
                   <a:srgbClr val="1A7A44"/>
                 </a:solidFill>
@@ -5975,7 +5899,7 @@
         </p:nvSpPr>
         <p:spPr>
           <a:xfrm>
-            <a:off x="749808" y="4423601"/>
+            <a:off x="749808" y="4481841"/>
             <a:ext cx="10692079" cy="470027"/>
           </a:xfrm>
           <a:prstGeom prst="rect">
@@ -5988,7 +5912,7 @@
           <a:bodyPr wrap="square" lIns="0" tIns="0" rIns="0" bIns="0" rtlCol="0" anchor="t"/>
           <a:lstStyle/>
           <a:p>
-            <a:pPr indent="0" marL="0">
+            <a:pPr marL="0" indent="0">
               <a:lnSpc>
                 <a:spcPct val="125000"/>
               </a:lnSpc>
@@ -6025,6 +5949,7 @@
         <a:solidFill>
           <a:srgbClr val="FFFFFF"/>
         </a:solidFill>
+        <a:effectLst/>
       </p:bgPr>
     </p:bg>
     <p:spTree>
@@ -6060,6 +5985,13 @@
           </a:solidFill>
           <a:ln/>
         </p:spPr>
+        <p:txBody>
+          <a:bodyPr/>
+          <a:lstStyle/>
+          <a:p>
+            <a:endParaRPr lang="en-ID"/>
+          </a:p>
+        </p:txBody>
       </p:sp>
       <p:sp>
         <p:nvSpPr>
@@ -6080,6 +6012,13 @@
           </a:solidFill>
           <a:ln/>
         </p:spPr>
+        <p:txBody>
+          <a:bodyPr/>
+          <a:lstStyle/>
+          <a:p>
+            <a:endParaRPr lang="en-ID"/>
+          </a:p>
+        </p:txBody>
       </p:sp>
       <p:sp>
         <p:nvSpPr>
@@ -6102,7 +6041,7 @@
           <a:bodyPr wrap="square" lIns="0" tIns="0" rIns="0" bIns="0" rtlCol="0" anchor="ctr"/>
           <a:lstStyle/>
           <a:p>
-            <a:pPr indent="0" marL="0">
+            <a:pPr marL="0" indent="0">
               <a:buNone/>
             </a:pPr>
             <a:r>
@@ -6116,9 +6055,6 @@
               </a:rPr>
               <a:t>belajar</a:t>
             </a:r>
-            <a:pPr indent="0" marL="0">
-              <a:buNone/>
-            </a:pPr>
             <a:r>
               <a:rPr lang="en-US" sz="2000" b="1" dirty="0">
                 <a:solidFill>
@@ -6155,7 +6091,7 @@
           <a:bodyPr wrap="square" lIns="0" tIns="0" rIns="0" bIns="0" rtlCol="0" anchor="ctr"/>
           <a:lstStyle/>
           <a:p>
-            <a:pPr algn="r" indent="0" marL="0">
+            <a:pPr marL="0" indent="0" algn="r">
               <a:buNone/>
             </a:pPr>
             <a:r>
@@ -6194,7 +6130,7 @@
           <a:bodyPr wrap="square" lIns="0" tIns="0" rIns="0" bIns="0" rtlCol="0" anchor="ctr"/>
           <a:lstStyle/>
           <a:p>
-            <a:pPr indent="0" marL="0">
+            <a:pPr marL="0" indent="0">
               <a:buNone/>
             </a:pPr>
             <a:r>
@@ -6233,11 +6169,11 @@
           <a:bodyPr wrap="square" lIns="0" tIns="0" rIns="0" bIns="0" rtlCol="0" anchor="ctr"/>
           <a:lstStyle/>
           <a:p>
-            <a:pPr indent="0" marL="0">
-              <a:buNone/>
-            </a:pPr>
-            <a:r>
-              <a:rPr lang="en-US" sz="1250" b="1" spc="40" kern="0" dirty="0">
+            <a:pPr marL="0" indent="0">
+              <a:buNone/>
+            </a:pPr>
+            <a:r>
+              <a:rPr lang="en-US" sz="1250" b="1" kern="0" spc="40" dirty="0">
                 <a:solidFill>
                   <a:srgbClr val="4B36C7"/>
                 </a:solidFill>
@@ -6272,7 +6208,7 @@
           <a:bodyPr wrap="square" lIns="0" tIns="0" rIns="0" bIns="0" rtlCol="0" anchor="t"/>
           <a:lstStyle/>
           <a:p>
-            <a:pPr indent="0" marL="0">
+            <a:pPr marL="0" indent="0">
               <a:lnSpc>
                 <a:spcPct val="125000"/>
               </a:lnSpc>
@@ -6314,11 +6250,11 @@
           <a:bodyPr wrap="square" lIns="0" tIns="0" rIns="0" bIns="0" rtlCol="0" anchor="ctr"/>
           <a:lstStyle/>
           <a:p>
-            <a:pPr indent="0" marL="0">
-              <a:buNone/>
-            </a:pPr>
-            <a:r>
-              <a:rPr lang="en-US" sz="1250" b="1" spc="40" kern="0" dirty="0">
+            <a:pPr marL="0" indent="0">
+              <a:buNone/>
+            </a:pPr>
+            <a:r>
+              <a:rPr lang="en-US" sz="1250" b="1" kern="0" spc="40" dirty="0">
                 <a:solidFill>
                   <a:srgbClr val="4B36C7"/>
                 </a:solidFill>
@@ -6340,8 +6276,8 @@
         </p:nvSpPr>
         <p:spPr>
           <a:xfrm>
-            <a:off x="548640" y="2811209"/>
-            <a:ext cx="11094415" cy="999744"/>
+            <a:off x="548640" y="2811208"/>
+            <a:ext cx="11094415" cy="1136905"/>
           </a:xfrm>
           <a:prstGeom prst="roundRect">
             <a:avLst>
@@ -6358,6 +6294,13 @@
             <a:prstDash val="solid"/>
           </a:ln>
         </p:spPr>
+        <p:txBody>
+          <a:bodyPr/>
+          <a:lstStyle/>
+          <a:p>
+            <a:endParaRPr lang="en-ID"/>
+          </a:p>
+        </p:txBody>
       </p:sp>
       <p:sp>
         <p:nvSpPr>
@@ -6380,11 +6323,11 @@
           <a:bodyPr wrap="square" lIns="0" tIns="0" rIns="0" bIns="0" rtlCol="0" anchor="ctr"/>
           <a:lstStyle/>
           <a:p>
-            <a:pPr indent="0" marL="0">
-              <a:buNone/>
-            </a:pPr>
-            <a:r>
-              <a:rPr lang="en-US" sz="950" b="1" spc="50" kern="0" dirty="0">
+            <a:pPr marL="0" indent="0">
+              <a:buNone/>
+            </a:pPr>
+            <a:r>
+              <a:rPr lang="en-US" sz="950" b="1" kern="0" spc="50" dirty="0">
                 <a:solidFill>
                   <a:srgbClr val="9AA2B4"/>
                 </a:solidFill>
@@ -6419,7 +6362,7 @@
           <a:bodyPr wrap="square" lIns="0" tIns="0" rIns="0" bIns="0" rtlCol="0" anchor="t"/>
           <a:lstStyle/>
           <a:p>
-            <a:pPr indent="0" marL="0">
+            <a:pPr marL="0" indent="0">
               <a:lnSpc>
                 <a:spcPct val="130000"/>
               </a:lnSpc>
@@ -6448,7 +6391,7 @@
         </p:nvSpPr>
         <p:spPr>
           <a:xfrm>
-            <a:off x="548640" y="4066984"/>
+            <a:off x="548640" y="4160170"/>
             <a:ext cx="11094415" cy="945515"/>
           </a:xfrm>
           <a:prstGeom prst="roundRect">
@@ -6466,6 +6409,13 @@
             <a:prstDash val="solid"/>
           </a:ln>
         </p:spPr>
+        <p:txBody>
+          <a:bodyPr/>
+          <a:lstStyle/>
+          <a:p>
+            <a:endParaRPr lang="en-ID"/>
+          </a:p>
+        </p:txBody>
       </p:sp>
       <p:sp>
         <p:nvSpPr>
@@ -6475,7 +6425,7 @@
         </p:nvSpPr>
         <p:spPr>
           <a:xfrm>
-            <a:off x="749808" y="4176712"/>
+            <a:off x="749808" y="4269898"/>
             <a:ext cx="10692079" cy="274320"/>
           </a:xfrm>
           <a:prstGeom prst="rect">
@@ -6488,11 +6438,11 @@
           <a:bodyPr wrap="square" lIns="0" tIns="0" rIns="0" bIns="0" rtlCol="0" anchor="ctr"/>
           <a:lstStyle/>
           <a:p>
-            <a:pPr indent="0" marL="0">
-              <a:buNone/>
-            </a:pPr>
-            <a:r>
-              <a:rPr lang="en-US" sz="1100" b="1" spc="40" kern="0" dirty="0">
+            <a:pPr marL="0" indent="0">
+              <a:buNone/>
+            </a:pPr>
+            <a:r>
+              <a:rPr lang="en-US" sz="1100" b="1" kern="0" spc="40" dirty="0">
                 <a:solidFill>
                   <a:srgbClr val="1A7A44"/>
                 </a:solidFill>
@@ -6514,7 +6464,7 @@
         </p:nvSpPr>
         <p:spPr>
           <a:xfrm>
-            <a:off x="749808" y="4423601"/>
+            <a:off x="749808" y="4516787"/>
             <a:ext cx="10692079" cy="470027"/>
           </a:xfrm>
           <a:prstGeom prst="rect">
@@ -6527,7 +6477,7 @@
           <a:bodyPr wrap="square" lIns="0" tIns="0" rIns="0" bIns="0" rtlCol="0" anchor="t"/>
           <a:lstStyle/>
           <a:p>
-            <a:pPr indent="0" marL="0">
+            <a:pPr marL="0" indent="0">
               <a:lnSpc>
                 <a:spcPct val="125000"/>
               </a:lnSpc>
@@ -6564,6 +6514,7 @@
         <a:solidFill>
           <a:srgbClr val="FFFFFF"/>
         </a:solidFill>
+        <a:effectLst/>
       </p:bgPr>
     </p:bg>
     <p:spTree>
@@ -6599,6 +6550,13 @@
           </a:solidFill>
           <a:ln/>
         </p:spPr>
+        <p:txBody>
+          <a:bodyPr/>
+          <a:lstStyle/>
+          <a:p>
+            <a:endParaRPr lang="en-ID"/>
+          </a:p>
+        </p:txBody>
       </p:sp>
       <p:sp>
         <p:nvSpPr>
@@ -6619,6 +6577,13 @@
           </a:solidFill>
           <a:ln/>
         </p:spPr>
+        <p:txBody>
+          <a:bodyPr/>
+          <a:lstStyle/>
+          <a:p>
+            <a:endParaRPr lang="en-ID"/>
+          </a:p>
+        </p:txBody>
       </p:sp>
       <p:sp>
         <p:nvSpPr>
@@ -6641,7 +6606,7 @@
           <a:bodyPr wrap="square" lIns="0" tIns="0" rIns="0" bIns="0" rtlCol="0" anchor="ctr"/>
           <a:lstStyle/>
           <a:p>
-            <a:pPr indent="0" marL="0">
+            <a:pPr marL="0" indent="0">
               <a:buNone/>
             </a:pPr>
             <a:r>
@@ -6655,9 +6620,6 @@
               </a:rPr>
               <a:t>belajar</a:t>
             </a:r>
-            <a:pPr indent="0" marL="0">
-              <a:buNone/>
-            </a:pPr>
             <a:r>
               <a:rPr lang="en-US" sz="2000" b="1" dirty="0">
                 <a:solidFill>
@@ -6694,7 +6656,7 @@
           <a:bodyPr wrap="square" lIns="0" tIns="0" rIns="0" bIns="0" rtlCol="0" anchor="ctr"/>
           <a:lstStyle/>
           <a:p>
-            <a:pPr algn="r" indent="0" marL="0">
+            <a:pPr marL="0" indent="0" algn="r">
               <a:buNone/>
             </a:pPr>
             <a:r>
@@ -6733,7 +6695,7 @@
           <a:bodyPr wrap="square" lIns="0" tIns="0" rIns="0" bIns="0" rtlCol="0" anchor="ctr"/>
           <a:lstStyle/>
           <a:p>
-            <a:pPr indent="0" marL="0">
+            <a:pPr marL="0" indent="0">
               <a:buNone/>
             </a:pPr>
             <a:r>
@@ -6772,11 +6734,11 @@
           <a:bodyPr wrap="square" lIns="0" tIns="0" rIns="0" bIns="0" rtlCol="0" anchor="ctr"/>
           <a:lstStyle/>
           <a:p>
-            <a:pPr indent="0" marL="0">
-              <a:buNone/>
-            </a:pPr>
-            <a:r>
-              <a:rPr lang="en-US" sz="1250" b="1" spc="40" kern="0" dirty="0">
+            <a:pPr marL="0" indent="0">
+              <a:buNone/>
+            </a:pPr>
+            <a:r>
+              <a:rPr lang="en-US" sz="1250" b="1" kern="0" spc="40" dirty="0">
                 <a:solidFill>
                   <a:srgbClr val="4B36C7"/>
                 </a:solidFill>
@@ -6811,7 +6773,7 @@
           <a:bodyPr wrap="square" lIns="0" tIns="0" rIns="0" bIns="0" rtlCol="0" anchor="t"/>
           <a:lstStyle/>
           <a:p>
-            <a:pPr indent="0" marL="0">
+            <a:pPr marL="0" indent="0">
               <a:lnSpc>
                 <a:spcPct val="125000"/>
               </a:lnSpc>
@@ -6853,11 +6815,11 @@
           <a:bodyPr wrap="square" lIns="0" tIns="0" rIns="0" bIns="0" rtlCol="0" anchor="ctr"/>
           <a:lstStyle/>
           <a:p>
-            <a:pPr indent="0" marL="0">
-              <a:buNone/>
-            </a:pPr>
-            <a:r>
-              <a:rPr lang="en-US" sz="1250" b="1" spc="40" kern="0" dirty="0">
+            <a:pPr marL="0" indent="0">
+              <a:buNone/>
+            </a:pPr>
+            <a:r>
+              <a:rPr lang="en-US" sz="1250" b="1" kern="0" spc="40" dirty="0">
                 <a:solidFill>
                   <a:srgbClr val="4B36C7"/>
                 </a:solidFill>
@@ -6879,8 +6841,8 @@
         </p:nvSpPr>
         <p:spPr>
           <a:xfrm>
-            <a:off x="548640" y="2811209"/>
-            <a:ext cx="11094415" cy="999744"/>
+            <a:off x="548640" y="2811208"/>
+            <a:ext cx="11094415" cy="1190019"/>
           </a:xfrm>
           <a:prstGeom prst="roundRect">
             <a:avLst>
@@ -6897,6 +6859,13 @@
             <a:prstDash val="solid"/>
           </a:ln>
         </p:spPr>
+        <p:txBody>
+          <a:bodyPr/>
+          <a:lstStyle/>
+          <a:p>
+            <a:endParaRPr lang="en-ID"/>
+          </a:p>
+        </p:txBody>
       </p:sp>
       <p:sp>
         <p:nvSpPr>
@@ -6919,11 +6888,11 @@
           <a:bodyPr wrap="square" lIns="0" tIns="0" rIns="0" bIns="0" rtlCol="0" anchor="ctr"/>
           <a:lstStyle/>
           <a:p>
-            <a:pPr indent="0" marL="0">
-              <a:buNone/>
-            </a:pPr>
-            <a:r>
-              <a:rPr lang="en-US" sz="950" b="1" spc="50" kern="0" dirty="0">
+            <a:pPr marL="0" indent="0">
+              <a:buNone/>
+            </a:pPr>
+            <a:r>
+              <a:rPr lang="en-US" sz="950" b="1" kern="0" spc="50" dirty="0">
                 <a:solidFill>
                   <a:srgbClr val="9AA2B4"/>
                 </a:solidFill>
@@ -6958,7 +6927,7 @@
           <a:bodyPr wrap="square" lIns="0" tIns="0" rIns="0" bIns="0" rtlCol="0" anchor="t"/>
           <a:lstStyle/>
           <a:p>
-            <a:pPr indent="0" marL="0">
+            <a:pPr marL="0" indent="0">
               <a:lnSpc>
                 <a:spcPct val="130000"/>
               </a:lnSpc>
@@ -6987,7 +6956,7 @@
         </p:nvSpPr>
         <p:spPr>
           <a:xfrm>
-            <a:off x="548640" y="4066984"/>
+            <a:off x="548640" y="4177642"/>
             <a:ext cx="11094415" cy="945515"/>
           </a:xfrm>
           <a:prstGeom prst="roundRect">
@@ -7005,6 +6974,13 @@
             <a:prstDash val="solid"/>
           </a:ln>
         </p:spPr>
+        <p:txBody>
+          <a:bodyPr/>
+          <a:lstStyle/>
+          <a:p>
+            <a:endParaRPr lang="en-ID"/>
+          </a:p>
+        </p:txBody>
       </p:sp>
       <p:sp>
         <p:nvSpPr>
@@ -7014,7 +6990,7 @@
         </p:nvSpPr>
         <p:spPr>
           <a:xfrm>
-            <a:off x="749808" y="4176712"/>
+            <a:off x="749808" y="4287370"/>
             <a:ext cx="10692079" cy="274320"/>
           </a:xfrm>
           <a:prstGeom prst="rect">
@@ -7027,11 +7003,11 @@
           <a:bodyPr wrap="square" lIns="0" tIns="0" rIns="0" bIns="0" rtlCol="0" anchor="ctr"/>
           <a:lstStyle/>
           <a:p>
-            <a:pPr indent="0" marL="0">
-              <a:buNone/>
-            </a:pPr>
-            <a:r>
-              <a:rPr lang="en-US" sz="1100" b="1" spc="40" kern="0" dirty="0">
+            <a:pPr marL="0" indent="0">
+              <a:buNone/>
+            </a:pPr>
+            <a:r>
+              <a:rPr lang="en-US" sz="1100" b="1" kern="0" spc="40" dirty="0">
                 <a:solidFill>
                   <a:srgbClr val="1A7A44"/>
                 </a:solidFill>
@@ -7053,7 +7029,7 @@
         </p:nvSpPr>
         <p:spPr>
           <a:xfrm>
-            <a:off x="749808" y="4423601"/>
+            <a:off x="749808" y="4534259"/>
             <a:ext cx="10692079" cy="470027"/>
           </a:xfrm>
           <a:prstGeom prst="rect">
@@ -7066,7 +7042,7 @@
           <a:bodyPr wrap="square" lIns="0" tIns="0" rIns="0" bIns="0" rtlCol="0" anchor="t"/>
           <a:lstStyle/>
           <a:p>
-            <a:pPr indent="0" marL="0">
+            <a:pPr marL="0" indent="0">
               <a:lnSpc>
                 <a:spcPct val="125000"/>
               </a:lnSpc>
@@ -7103,6 +7079,7 @@
         <a:solidFill>
           <a:srgbClr val="FFFFFF"/>
         </a:solidFill>
+        <a:effectLst/>
       </p:bgPr>
     </p:bg>
     <p:spTree>
@@ -7138,6 +7115,13 @@
           </a:solidFill>
           <a:ln/>
         </p:spPr>
+        <p:txBody>
+          <a:bodyPr/>
+          <a:lstStyle/>
+          <a:p>
+            <a:endParaRPr lang="en-ID"/>
+          </a:p>
+        </p:txBody>
       </p:sp>
       <p:sp>
         <p:nvSpPr>
@@ -7158,6 +7142,13 @@
           </a:solidFill>
           <a:ln/>
         </p:spPr>
+        <p:txBody>
+          <a:bodyPr/>
+          <a:lstStyle/>
+          <a:p>
+            <a:endParaRPr lang="en-ID"/>
+          </a:p>
+        </p:txBody>
       </p:sp>
       <p:sp>
         <p:nvSpPr>
@@ -7180,7 +7171,7 @@
           <a:bodyPr wrap="square" lIns="0" tIns="0" rIns="0" bIns="0" rtlCol="0" anchor="ctr"/>
           <a:lstStyle/>
           <a:p>
-            <a:pPr indent="0" marL="0">
+            <a:pPr marL="0" indent="0">
               <a:buNone/>
             </a:pPr>
             <a:r>
@@ -7194,9 +7185,6 @@
               </a:rPr>
               <a:t>belajar</a:t>
             </a:r>
-            <a:pPr indent="0" marL="0">
-              <a:buNone/>
-            </a:pPr>
             <a:r>
               <a:rPr lang="en-US" sz="2000" b="1" dirty="0">
                 <a:solidFill>
@@ -7233,7 +7221,7 @@
           <a:bodyPr wrap="square" lIns="0" tIns="0" rIns="0" bIns="0" rtlCol="0" anchor="ctr"/>
           <a:lstStyle/>
           <a:p>
-            <a:pPr algn="r" indent="0" marL="0">
+            <a:pPr marL="0" indent="0" algn="r">
               <a:buNone/>
             </a:pPr>
             <a:r>
@@ -7272,7 +7260,7 @@
           <a:bodyPr wrap="square" lIns="0" tIns="0" rIns="0" bIns="0" rtlCol="0" anchor="ctr"/>
           <a:lstStyle/>
           <a:p>
-            <a:pPr indent="0" marL="0">
+            <a:pPr marL="0" indent="0">
               <a:buNone/>
             </a:pPr>
             <a:r>
@@ -7311,11 +7299,11 @@
           <a:bodyPr wrap="square" lIns="0" tIns="0" rIns="0" bIns="0" rtlCol="0" anchor="ctr"/>
           <a:lstStyle/>
           <a:p>
-            <a:pPr indent="0" marL="0">
-              <a:buNone/>
-            </a:pPr>
-            <a:r>
-              <a:rPr lang="en-US" sz="1250" b="1" spc="40" kern="0" dirty="0">
+            <a:pPr marL="0" indent="0">
+              <a:buNone/>
+            </a:pPr>
+            <a:r>
+              <a:rPr lang="en-US" sz="1250" b="1" kern="0" spc="40" dirty="0">
                 <a:solidFill>
                   <a:srgbClr val="4B36C7"/>
                 </a:solidFill>
@@ -7350,7 +7338,7 @@
           <a:bodyPr wrap="square" lIns="0" tIns="0" rIns="0" bIns="0" rtlCol="0" anchor="t"/>
           <a:lstStyle/>
           <a:p>
-            <a:pPr indent="0" marL="0">
+            <a:pPr marL="0" indent="0">
               <a:lnSpc>
                 <a:spcPct val="125000"/>
               </a:lnSpc>
@@ -7392,11 +7380,11 @@
           <a:bodyPr wrap="square" lIns="0" tIns="0" rIns="0" bIns="0" rtlCol="0" anchor="ctr"/>
           <a:lstStyle/>
           <a:p>
-            <a:pPr indent="0" marL="0">
-              <a:buNone/>
-            </a:pPr>
-            <a:r>
-              <a:rPr lang="en-US" sz="1250" b="1" spc="40" kern="0" dirty="0">
+            <a:pPr marL="0" indent="0">
+              <a:buNone/>
+            </a:pPr>
+            <a:r>
+              <a:rPr lang="en-US" sz="1250" b="1" kern="0" spc="40" dirty="0">
                 <a:solidFill>
                   <a:srgbClr val="4B36C7"/>
                 </a:solidFill>
@@ -7436,6 +7424,13 @@
             <a:prstDash val="solid"/>
           </a:ln>
         </p:spPr>
+        <p:txBody>
+          <a:bodyPr/>
+          <a:lstStyle/>
+          <a:p>
+            <a:endParaRPr lang="en-ID"/>
+          </a:p>
+        </p:txBody>
       </p:sp>
       <p:sp>
         <p:nvSpPr>
@@ -7458,11 +7453,11 @@
           <a:bodyPr wrap="square" lIns="0" tIns="0" rIns="0" bIns="0" rtlCol="0" anchor="ctr"/>
           <a:lstStyle/>
           <a:p>
-            <a:pPr indent="0" marL="0">
-              <a:buNone/>
-            </a:pPr>
-            <a:r>
-              <a:rPr lang="en-US" sz="950" b="1" spc="50" kern="0" dirty="0">
+            <a:pPr marL="0" indent="0">
+              <a:buNone/>
+            </a:pPr>
+            <a:r>
+              <a:rPr lang="en-US" sz="950" b="1" kern="0" spc="50" dirty="0">
                 <a:solidFill>
                   <a:srgbClr val="9AA2B4"/>
                 </a:solidFill>
@@ -7497,7 +7492,7 @@
           <a:bodyPr wrap="square" lIns="0" tIns="0" rIns="0" bIns="0" rtlCol="0" anchor="t"/>
           <a:lstStyle/>
           <a:p>
-            <a:pPr indent="0" marL="0">
+            <a:pPr marL="0" indent="0">
               <a:lnSpc>
                 <a:spcPct val="130000"/>
               </a:lnSpc>
@@ -7544,6 +7539,13 @@
             <a:prstDash val="solid"/>
           </a:ln>
         </p:spPr>
+        <p:txBody>
+          <a:bodyPr/>
+          <a:lstStyle/>
+          <a:p>
+            <a:endParaRPr lang="en-ID"/>
+          </a:p>
+        </p:txBody>
       </p:sp>
       <p:sp>
         <p:nvSpPr>
@@ -7566,11 +7568,11 @@
           <a:bodyPr wrap="square" lIns="0" tIns="0" rIns="0" bIns="0" rtlCol="0" anchor="ctr"/>
           <a:lstStyle/>
           <a:p>
-            <a:pPr indent="0" marL="0">
-              <a:buNone/>
-            </a:pPr>
-            <a:r>
-              <a:rPr lang="en-US" sz="1100" b="1" spc="40" kern="0" dirty="0">
+            <a:pPr marL="0" indent="0">
+              <a:buNone/>
+            </a:pPr>
+            <a:r>
+              <a:rPr lang="en-US" sz="1100" b="1" kern="0" spc="40" dirty="0">
                 <a:solidFill>
                   <a:srgbClr val="1A7A44"/>
                 </a:solidFill>
@@ -7605,7 +7607,7 @@
           <a:bodyPr wrap="square" lIns="0" tIns="0" rIns="0" bIns="0" rtlCol="0" anchor="t"/>
           <a:lstStyle/>
           <a:p>
-            <a:pPr indent="0" marL="0">
+            <a:pPr marL="0" indent="0">
               <a:lnSpc>
                 <a:spcPct val="125000"/>
               </a:lnSpc>
@@ -7642,6 +7644,7 @@
         <a:solidFill>
           <a:srgbClr val="FFFFFF"/>
         </a:solidFill>
+        <a:effectLst/>
       </p:bgPr>
     </p:bg>
     <p:spTree>
@@ -7677,6 +7680,13 @@
           </a:solidFill>
           <a:ln/>
         </p:spPr>
+        <p:txBody>
+          <a:bodyPr/>
+          <a:lstStyle/>
+          <a:p>
+            <a:endParaRPr lang="en-ID"/>
+          </a:p>
+        </p:txBody>
       </p:sp>
       <p:sp>
         <p:nvSpPr>
@@ -7697,6 +7707,13 @@
           </a:solidFill>
           <a:ln/>
         </p:spPr>
+        <p:txBody>
+          <a:bodyPr/>
+          <a:lstStyle/>
+          <a:p>
+            <a:endParaRPr lang="en-ID"/>
+          </a:p>
+        </p:txBody>
       </p:sp>
       <p:sp>
         <p:nvSpPr>
@@ -7719,7 +7736,7 @@
           <a:bodyPr wrap="square" lIns="0" tIns="0" rIns="0" bIns="0" rtlCol="0" anchor="ctr"/>
           <a:lstStyle/>
           <a:p>
-            <a:pPr indent="0" marL="0">
+            <a:pPr marL="0" indent="0">
               <a:buNone/>
             </a:pPr>
             <a:r>
@@ -7733,9 +7750,6 @@
               </a:rPr>
               <a:t>belajar</a:t>
             </a:r>
-            <a:pPr indent="0" marL="0">
-              <a:buNone/>
-            </a:pPr>
             <a:r>
               <a:rPr lang="en-US" sz="2000" b="1" dirty="0">
                 <a:solidFill>
@@ -7772,7 +7786,7 @@
           <a:bodyPr wrap="square" lIns="0" tIns="0" rIns="0" bIns="0" rtlCol="0" anchor="ctr"/>
           <a:lstStyle/>
           <a:p>
-            <a:pPr algn="r" indent="0" marL="0">
+            <a:pPr marL="0" indent="0" algn="r">
               <a:buNone/>
             </a:pPr>
             <a:r>
@@ -7811,7 +7825,7 @@
           <a:bodyPr wrap="square" lIns="0" tIns="0" rIns="0" bIns="0" rtlCol="0" anchor="ctr"/>
           <a:lstStyle/>
           <a:p>
-            <a:pPr indent="0" marL="0">
+            <a:pPr marL="0" indent="0">
               <a:buNone/>
             </a:pPr>
             <a:r>
@@ -7850,11 +7864,11 @@
           <a:bodyPr wrap="square" lIns="0" tIns="0" rIns="0" bIns="0" rtlCol="0" anchor="ctr"/>
           <a:lstStyle/>
           <a:p>
-            <a:pPr indent="0" marL="0">
-              <a:buNone/>
-            </a:pPr>
-            <a:r>
-              <a:rPr lang="en-US" sz="1250" b="1" spc="40" kern="0" dirty="0">
+            <a:pPr marL="0" indent="0">
+              <a:buNone/>
+            </a:pPr>
+            <a:r>
+              <a:rPr lang="en-US" sz="1250" b="1" kern="0" spc="40" dirty="0">
                 <a:solidFill>
                   <a:srgbClr val="4B36C7"/>
                 </a:solidFill>
@@ -7889,7 +7903,7 @@
           <a:bodyPr wrap="square" lIns="0" tIns="0" rIns="0" bIns="0" rtlCol="0" anchor="t"/>
           <a:lstStyle/>
           <a:p>
-            <a:pPr indent="0" marL="0">
+            <a:pPr marL="0" indent="0">
               <a:lnSpc>
                 <a:spcPct val="125000"/>
               </a:lnSpc>
@@ -7931,11 +7945,11 @@
           <a:bodyPr wrap="square" lIns="0" tIns="0" rIns="0" bIns="0" rtlCol="0" anchor="ctr"/>
           <a:lstStyle/>
           <a:p>
-            <a:pPr indent="0" marL="0">
-              <a:buNone/>
-            </a:pPr>
-            <a:r>
-              <a:rPr lang="en-US" sz="1250" b="1" spc="40" kern="0" dirty="0">
+            <a:pPr marL="0" indent="0">
+              <a:buNone/>
+            </a:pPr>
+            <a:r>
+              <a:rPr lang="en-US" sz="1250" b="1" kern="0" spc="40" dirty="0">
                 <a:solidFill>
                   <a:srgbClr val="4B36C7"/>
                 </a:solidFill>
@@ -7957,8 +7971,8 @@
         </p:nvSpPr>
         <p:spPr>
           <a:xfrm>
-            <a:off x="548640" y="2811209"/>
-            <a:ext cx="11094415" cy="999744"/>
+            <a:off x="548640" y="2811208"/>
+            <a:ext cx="11094415" cy="1184195"/>
           </a:xfrm>
           <a:prstGeom prst="roundRect">
             <a:avLst>
@@ -7975,6 +7989,13 @@
             <a:prstDash val="solid"/>
           </a:ln>
         </p:spPr>
+        <p:txBody>
+          <a:bodyPr/>
+          <a:lstStyle/>
+          <a:p>
+            <a:endParaRPr lang="en-ID"/>
+          </a:p>
+        </p:txBody>
       </p:sp>
       <p:sp>
         <p:nvSpPr>
@@ -7997,11 +8018,11 @@
           <a:bodyPr wrap="square" lIns="0" tIns="0" rIns="0" bIns="0" rtlCol="0" anchor="ctr"/>
           <a:lstStyle/>
           <a:p>
-            <a:pPr indent="0" marL="0">
-              <a:buNone/>
-            </a:pPr>
-            <a:r>
-              <a:rPr lang="en-US" sz="950" b="1" spc="50" kern="0" dirty="0">
+            <a:pPr marL="0" indent="0">
+              <a:buNone/>
+            </a:pPr>
+            <a:r>
+              <a:rPr lang="en-US" sz="950" b="1" kern="0" spc="50" dirty="0">
                 <a:solidFill>
                   <a:srgbClr val="9AA2B4"/>
                 </a:solidFill>
@@ -8036,7 +8057,7 @@
           <a:bodyPr wrap="square" lIns="0" tIns="0" rIns="0" bIns="0" rtlCol="0" anchor="t"/>
           <a:lstStyle/>
           <a:p>
-            <a:pPr indent="0" marL="0">
+            <a:pPr marL="0" indent="0">
               <a:lnSpc>
                 <a:spcPct val="130000"/>
               </a:lnSpc>
@@ -8065,7 +8086,7 @@
         </p:nvSpPr>
         <p:spPr>
           <a:xfrm>
-            <a:off x="548640" y="4066984"/>
+            <a:off x="548640" y="4200942"/>
             <a:ext cx="11094415" cy="945515"/>
           </a:xfrm>
           <a:prstGeom prst="roundRect">
@@ -8083,6 +8104,13 @@
             <a:prstDash val="solid"/>
           </a:ln>
         </p:spPr>
+        <p:txBody>
+          <a:bodyPr/>
+          <a:lstStyle/>
+          <a:p>
+            <a:endParaRPr lang="en-ID"/>
+          </a:p>
+        </p:txBody>
       </p:sp>
       <p:sp>
         <p:nvSpPr>
@@ -8092,7 +8120,7 @@
         </p:nvSpPr>
         <p:spPr>
           <a:xfrm>
-            <a:off x="749808" y="4176712"/>
+            <a:off x="749808" y="4310670"/>
             <a:ext cx="10692079" cy="274320"/>
           </a:xfrm>
           <a:prstGeom prst="rect">
@@ -8105,11 +8133,11 @@
           <a:bodyPr wrap="square" lIns="0" tIns="0" rIns="0" bIns="0" rtlCol="0" anchor="ctr"/>
           <a:lstStyle/>
           <a:p>
-            <a:pPr indent="0" marL="0">
-              <a:buNone/>
-            </a:pPr>
-            <a:r>
-              <a:rPr lang="en-US" sz="1100" b="1" spc="40" kern="0" dirty="0">
+            <a:pPr marL="0" indent="0">
+              <a:buNone/>
+            </a:pPr>
+            <a:r>
+              <a:rPr lang="en-US" sz="1100" b="1" kern="0" spc="40" dirty="0">
                 <a:solidFill>
                   <a:srgbClr val="1A7A44"/>
                 </a:solidFill>
@@ -8131,7 +8159,7 @@
         </p:nvSpPr>
         <p:spPr>
           <a:xfrm>
-            <a:off x="749808" y="4423601"/>
+            <a:off x="749808" y="4557559"/>
             <a:ext cx="10692079" cy="470027"/>
           </a:xfrm>
           <a:prstGeom prst="rect">
@@ -8144,7 +8172,7 @@
           <a:bodyPr wrap="square" lIns="0" tIns="0" rIns="0" bIns="0" rtlCol="0" anchor="t"/>
           <a:lstStyle/>
           <a:p>
-            <a:pPr indent="0" marL="0">
+            <a:pPr marL="0" indent="0">
               <a:lnSpc>
                 <a:spcPct val="125000"/>
               </a:lnSpc>
@@ -8181,6 +8209,7 @@
         <a:solidFill>
           <a:srgbClr val="FFFFFF"/>
         </a:solidFill>
+        <a:effectLst/>
       </p:bgPr>
     </p:bg>
     <p:spTree>
@@ -8216,6 +8245,13 @@
           </a:solidFill>
           <a:ln/>
         </p:spPr>
+        <p:txBody>
+          <a:bodyPr/>
+          <a:lstStyle/>
+          <a:p>
+            <a:endParaRPr lang="en-ID"/>
+          </a:p>
+        </p:txBody>
       </p:sp>
       <p:sp>
         <p:nvSpPr>
@@ -8236,6 +8272,13 @@
           </a:solidFill>
           <a:ln/>
         </p:spPr>
+        <p:txBody>
+          <a:bodyPr/>
+          <a:lstStyle/>
+          <a:p>
+            <a:endParaRPr lang="en-ID"/>
+          </a:p>
+        </p:txBody>
       </p:sp>
       <p:sp>
         <p:nvSpPr>
@@ -8258,7 +8301,7 @@
           <a:bodyPr wrap="square" lIns="0" tIns="0" rIns="0" bIns="0" rtlCol="0" anchor="ctr"/>
           <a:lstStyle/>
           <a:p>
-            <a:pPr indent="0" marL="0">
+            <a:pPr marL="0" indent="0">
               <a:buNone/>
             </a:pPr>
             <a:r>
@@ -8272,9 +8315,6 @@
               </a:rPr>
               <a:t>belajar</a:t>
             </a:r>
-            <a:pPr indent="0" marL="0">
-              <a:buNone/>
-            </a:pPr>
             <a:r>
               <a:rPr lang="en-US" sz="2000" b="1" dirty="0">
                 <a:solidFill>
@@ -8311,7 +8351,7 @@
           <a:bodyPr wrap="square" lIns="0" tIns="0" rIns="0" bIns="0" rtlCol="0" anchor="ctr"/>
           <a:lstStyle/>
           <a:p>
-            <a:pPr algn="r" indent="0" marL="0">
+            <a:pPr marL="0" indent="0" algn="r">
               <a:buNone/>
             </a:pPr>
             <a:r>
@@ -8350,7 +8390,7 @@
           <a:bodyPr wrap="square" lIns="0" tIns="0" rIns="0" bIns="0" rtlCol="0" anchor="ctr"/>
           <a:lstStyle/>
           <a:p>
-            <a:pPr indent="0" marL="0">
+            <a:pPr marL="0" indent="0">
               <a:buNone/>
             </a:pPr>
             <a:r>
@@ -8389,11 +8429,11 @@
           <a:bodyPr wrap="square" lIns="0" tIns="0" rIns="0" bIns="0" rtlCol="0" anchor="ctr"/>
           <a:lstStyle/>
           <a:p>
-            <a:pPr indent="0" marL="0">
-              <a:buNone/>
-            </a:pPr>
-            <a:r>
-              <a:rPr lang="en-US" sz="1250" b="1" spc="40" kern="0" dirty="0">
+            <a:pPr marL="0" indent="0">
+              <a:buNone/>
+            </a:pPr>
+            <a:r>
+              <a:rPr lang="en-US" sz="1250" b="1" kern="0" spc="40" dirty="0">
                 <a:solidFill>
                   <a:srgbClr val="4B36C7"/>
                 </a:solidFill>
@@ -8428,7 +8468,7 @@
           <a:bodyPr wrap="square" lIns="0" tIns="0" rIns="0" bIns="0" rtlCol="0" anchor="t"/>
           <a:lstStyle/>
           <a:p>
-            <a:pPr indent="0" marL="0">
+            <a:pPr marL="0" indent="0">
               <a:lnSpc>
                 <a:spcPct val="125000"/>
               </a:lnSpc>
@@ -8470,11 +8510,11 @@
           <a:bodyPr wrap="square" lIns="0" tIns="0" rIns="0" bIns="0" rtlCol="0" anchor="ctr"/>
           <a:lstStyle/>
           <a:p>
-            <a:pPr indent="0" marL="0">
-              <a:buNone/>
-            </a:pPr>
-            <a:r>
-              <a:rPr lang="en-US" sz="1250" b="1" spc="40" kern="0" dirty="0">
+            <a:pPr marL="0" indent="0">
+              <a:buNone/>
+            </a:pPr>
+            <a:r>
+              <a:rPr lang="en-US" sz="1250" b="1" kern="0" spc="40" dirty="0">
                 <a:solidFill>
                   <a:srgbClr val="4B36C7"/>
                 </a:solidFill>
@@ -8496,8 +8536,8 @@
         </p:nvSpPr>
         <p:spPr>
           <a:xfrm>
-            <a:off x="548640" y="2811209"/>
-            <a:ext cx="11094415" cy="999744"/>
+            <a:off x="548640" y="2811208"/>
+            <a:ext cx="11094415" cy="1178371"/>
           </a:xfrm>
           <a:prstGeom prst="roundRect">
             <a:avLst>
@@ -8514,6 +8554,13 @@
             <a:prstDash val="solid"/>
           </a:ln>
         </p:spPr>
+        <p:txBody>
+          <a:bodyPr/>
+          <a:lstStyle/>
+          <a:p>
+            <a:endParaRPr lang="en-ID"/>
+          </a:p>
+        </p:txBody>
       </p:sp>
       <p:sp>
         <p:nvSpPr>
@@ -8536,11 +8583,11 @@
           <a:bodyPr wrap="square" lIns="0" tIns="0" rIns="0" bIns="0" rtlCol="0" anchor="ctr"/>
           <a:lstStyle/>
           <a:p>
-            <a:pPr indent="0" marL="0">
-              <a:buNone/>
-            </a:pPr>
-            <a:r>
-              <a:rPr lang="en-US" sz="950" b="1" spc="50" kern="0" dirty="0">
+            <a:pPr marL="0" indent="0">
+              <a:buNone/>
+            </a:pPr>
+            <a:r>
+              <a:rPr lang="en-US" sz="950" b="1" kern="0" spc="50" dirty="0">
                 <a:solidFill>
                   <a:srgbClr val="9AA2B4"/>
                 </a:solidFill>
@@ -8575,7 +8622,7 @@
           <a:bodyPr wrap="square" lIns="0" tIns="0" rIns="0" bIns="0" rtlCol="0" anchor="t"/>
           <a:lstStyle/>
           <a:p>
-            <a:pPr indent="0" marL="0">
+            <a:pPr marL="0" indent="0">
               <a:lnSpc>
                 <a:spcPct val="130000"/>
               </a:lnSpc>
@@ -8604,7 +8651,7 @@
         </p:nvSpPr>
         <p:spPr>
           <a:xfrm>
-            <a:off x="548640" y="4066984"/>
+            <a:off x="548640" y="4177642"/>
             <a:ext cx="11094415" cy="945515"/>
           </a:xfrm>
           <a:prstGeom prst="roundRect">
@@ -8622,6 +8669,13 @@
             <a:prstDash val="solid"/>
           </a:ln>
         </p:spPr>
+        <p:txBody>
+          <a:bodyPr/>
+          <a:lstStyle/>
+          <a:p>
+            <a:endParaRPr lang="en-ID"/>
+          </a:p>
+        </p:txBody>
       </p:sp>
       <p:sp>
         <p:nvSpPr>
@@ -8631,7 +8685,7 @@
         </p:nvSpPr>
         <p:spPr>
           <a:xfrm>
-            <a:off x="749808" y="4176712"/>
+            <a:off x="749808" y="4287370"/>
             <a:ext cx="10692079" cy="274320"/>
           </a:xfrm>
           <a:prstGeom prst="rect">
@@ -8644,11 +8698,11 @@
           <a:bodyPr wrap="square" lIns="0" tIns="0" rIns="0" bIns="0" rtlCol="0" anchor="ctr"/>
           <a:lstStyle/>
           <a:p>
-            <a:pPr indent="0" marL="0">
-              <a:buNone/>
-            </a:pPr>
-            <a:r>
-              <a:rPr lang="en-US" sz="1100" b="1" spc="40" kern="0" dirty="0">
+            <a:pPr marL="0" indent="0">
+              <a:buNone/>
+            </a:pPr>
+            <a:r>
+              <a:rPr lang="en-US" sz="1100" b="1" kern="0" spc="40" dirty="0">
                 <a:solidFill>
                   <a:srgbClr val="1A7A44"/>
                 </a:solidFill>
@@ -8670,7 +8724,7 @@
         </p:nvSpPr>
         <p:spPr>
           <a:xfrm>
-            <a:off x="749808" y="4423601"/>
+            <a:off x="749808" y="4534259"/>
             <a:ext cx="10692079" cy="470027"/>
           </a:xfrm>
           <a:prstGeom prst="rect">
@@ -8683,7 +8737,7 @@
           <a:bodyPr wrap="square" lIns="0" tIns="0" rIns="0" bIns="0" rtlCol="0" anchor="t"/>
           <a:lstStyle/>
           <a:p>
-            <a:pPr indent="0" marL="0">
+            <a:pPr marL="0" indent="0">
               <a:lnSpc>
                 <a:spcPct val="125000"/>
               </a:lnSpc>
@@ -8720,6 +8774,7 @@
         <a:solidFill>
           <a:srgbClr val="FFFFFF"/>
         </a:solidFill>
+        <a:effectLst/>
       </p:bgPr>
     </p:bg>
     <p:spTree>
@@ -8755,6 +8810,13 @@
           </a:solidFill>
           <a:ln/>
         </p:spPr>
+        <p:txBody>
+          <a:bodyPr/>
+          <a:lstStyle/>
+          <a:p>
+            <a:endParaRPr lang="en-ID"/>
+          </a:p>
+        </p:txBody>
       </p:sp>
       <p:sp>
         <p:nvSpPr>
@@ -8775,6 +8837,13 @@
           </a:solidFill>
           <a:ln/>
         </p:spPr>
+        <p:txBody>
+          <a:bodyPr/>
+          <a:lstStyle/>
+          <a:p>
+            <a:endParaRPr lang="en-ID"/>
+          </a:p>
+        </p:txBody>
       </p:sp>
       <p:sp>
         <p:nvSpPr>
@@ -8797,7 +8866,7 @@
           <a:bodyPr wrap="square" lIns="0" tIns="0" rIns="0" bIns="0" rtlCol="0" anchor="ctr"/>
           <a:lstStyle/>
           <a:p>
-            <a:pPr indent="0" marL="0">
+            <a:pPr marL="0" indent="0">
               <a:buNone/>
             </a:pPr>
             <a:r>
@@ -8811,9 +8880,6 @@
               </a:rPr>
               <a:t>belajar</a:t>
             </a:r>
-            <a:pPr indent="0" marL="0">
-              <a:buNone/>
-            </a:pPr>
             <a:r>
               <a:rPr lang="en-US" sz="2000" b="1" dirty="0">
                 <a:solidFill>
@@ -8850,7 +8916,7 @@
           <a:bodyPr wrap="square" lIns="0" tIns="0" rIns="0" bIns="0" rtlCol="0" anchor="ctr"/>
           <a:lstStyle/>
           <a:p>
-            <a:pPr algn="r" indent="0" marL="0">
+            <a:pPr marL="0" indent="0" algn="r">
               <a:buNone/>
             </a:pPr>
             <a:r>
@@ -8889,7 +8955,7 @@
           <a:bodyPr wrap="square" lIns="0" tIns="0" rIns="0" bIns="0" rtlCol="0" anchor="ctr"/>
           <a:lstStyle/>
           <a:p>
-            <a:pPr indent="0" marL="0">
+            <a:pPr marL="0" indent="0">
               <a:buNone/>
             </a:pPr>
             <a:r>
@@ -8928,11 +8994,11 @@
           <a:bodyPr wrap="square" lIns="0" tIns="0" rIns="0" bIns="0" rtlCol="0" anchor="ctr"/>
           <a:lstStyle/>
           <a:p>
-            <a:pPr indent="0" marL="0">
-              <a:buNone/>
-            </a:pPr>
-            <a:r>
-              <a:rPr lang="en-US" sz="1250" b="1" spc="40" kern="0" dirty="0">
+            <a:pPr marL="0" indent="0">
+              <a:buNone/>
+            </a:pPr>
+            <a:r>
+              <a:rPr lang="en-US" sz="1250" b="1" kern="0" spc="40" dirty="0">
                 <a:solidFill>
                   <a:srgbClr val="4B36C7"/>
                 </a:solidFill>
@@ -8967,7 +9033,7 @@
           <a:bodyPr wrap="square" lIns="0" tIns="0" rIns="0" bIns="0" rtlCol="0" anchor="t"/>
           <a:lstStyle/>
           <a:p>
-            <a:pPr indent="0" marL="0">
+            <a:pPr marL="0" indent="0">
               <a:lnSpc>
                 <a:spcPct val="125000"/>
               </a:lnSpc>
@@ -9009,11 +9075,11 @@
           <a:bodyPr wrap="square" lIns="0" tIns="0" rIns="0" bIns="0" rtlCol="0" anchor="ctr"/>
           <a:lstStyle/>
           <a:p>
-            <a:pPr indent="0" marL="0">
-              <a:buNone/>
-            </a:pPr>
-            <a:r>
-              <a:rPr lang="en-US" sz="1250" b="1" spc="40" kern="0" dirty="0">
+            <a:pPr marL="0" indent="0">
+              <a:buNone/>
+            </a:pPr>
+            <a:r>
+              <a:rPr lang="en-US" sz="1250" b="1" kern="0" spc="40" dirty="0">
                 <a:solidFill>
                   <a:srgbClr val="4B36C7"/>
                 </a:solidFill>
@@ -9053,6 +9119,13 @@
             <a:prstDash val="solid"/>
           </a:ln>
         </p:spPr>
+        <p:txBody>
+          <a:bodyPr/>
+          <a:lstStyle/>
+          <a:p>
+            <a:endParaRPr lang="en-ID"/>
+          </a:p>
+        </p:txBody>
       </p:sp>
       <p:sp>
         <p:nvSpPr>
@@ -9075,11 +9148,11 @@
           <a:bodyPr wrap="square" lIns="0" tIns="0" rIns="0" bIns="0" rtlCol="0" anchor="ctr"/>
           <a:lstStyle/>
           <a:p>
-            <a:pPr indent="0" marL="0">
-              <a:buNone/>
-            </a:pPr>
-            <a:r>
-              <a:rPr lang="en-US" sz="950" b="1" spc="50" kern="0" dirty="0">
+            <a:pPr marL="0" indent="0">
+              <a:buNone/>
+            </a:pPr>
+            <a:r>
+              <a:rPr lang="en-US" sz="950" b="1" kern="0" spc="50" dirty="0">
                 <a:solidFill>
                   <a:srgbClr val="9AA2B4"/>
                 </a:solidFill>
@@ -9114,7 +9187,7 @@
           <a:bodyPr wrap="square" lIns="0" tIns="0" rIns="0" bIns="0" rtlCol="0" anchor="t"/>
           <a:lstStyle/>
           <a:p>
-            <a:pPr indent="0" marL="0">
+            <a:pPr marL="0" indent="0">
               <a:lnSpc>
                 <a:spcPct val="130000"/>
               </a:lnSpc>
@@ -9161,6 +9234,13 @@
             <a:prstDash val="solid"/>
           </a:ln>
         </p:spPr>
+        <p:txBody>
+          <a:bodyPr/>
+          <a:lstStyle/>
+          <a:p>
+            <a:endParaRPr lang="en-ID"/>
+          </a:p>
+        </p:txBody>
       </p:sp>
       <p:sp>
         <p:nvSpPr>
@@ -9183,11 +9263,11 @@
           <a:bodyPr wrap="square" lIns="0" tIns="0" rIns="0" bIns="0" rtlCol="0" anchor="ctr"/>
           <a:lstStyle/>
           <a:p>
-            <a:pPr indent="0" marL="0">
-              <a:buNone/>
-            </a:pPr>
-            <a:r>
-              <a:rPr lang="en-US" sz="1100" b="1" spc="40" kern="0" dirty="0">
+            <a:pPr marL="0" indent="0">
+              <a:buNone/>
+            </a:pPr>
+            <a:r>
+              <a:rPr lang="en-US" sz="1100" b="1" kern="0" spc="40" dirty="0">
                 <a:solidFill>
                   <a:srgbClr val="1A7A44"/>
                 </a:solidFill>
@@ -9222,7 +9302,7 @@
           <a:bodyPr wrap="square" lIns="0" tIns="0" rIns="0" bIns="0" rtlCol="0" anchor="t"/>
           <a:lstStyle/>
           <a:p>
-            <a:pPr indent="0" marL="0">
+            <a:pPr marL="0" indent="0">
               <a:lnSpc>
                 <a:spcPct val="125000"/>
               </a:lnSpc>
@@ -9544,4 +9624,319 @@
     </a:ext>
   </a:extLst>
 </a:theme>
+</file>
+
+<file path=ppt/theme/theme2.xml><?xml version="1.0" encoding="utf-8"?>
+<a:theme xmlns:a="http://schemas.openxmlformats.org/drawingml/2006/main" name="Office Theme">
+  <a:themeElements>
+    <a:clrScheme name="Office">
+      <a:dk1>
+        <a:sysClr val="windowText" lastClr="000000"/>
+      </a:dk1>
+      <a:lt1>
+        <a:sysClr val="window" lastClr="FFFFFF"/>
+      </a:lt1>
+      <a:dk2>
+        <a:srgbClr val="0E2841"/>
+      </a:dk2>
+      <a:lt2>
+        <a:srgbClr val="E8E8E8"/>
+      </a:lt2>
+      <a:accent1>
+        <a:srgbClr val="156082"/>
+      </a:accent1>
+      <a:accent2>
+        <a:srgbClr val="E97132"/>
+      </a:accent2>
+      <a:accent3>
+        <a:srgbClr val="196B24"/>
+      </a:accent3>
+      <a:accent4>
+        <a:srgbClr val="0F9ED5"/>
+      </a:accent4>
+      <a:accent5>
+        <a:srgbClr val="A02B93"/>
+      </a:accent5>
+      <a:accent6>
+        <a:srgbClr val="4EA72E"/>
+      </a:accent6>
+      <a:hlink>
+        <a:srgbClr val="467886"/>
+      </a:hlink>
+      <a:folHlink>
+        <a:srgbClr val="96607D"/>
+      </a:folHlink>
+    </a:clrScheme>
+    <a:fontScheme name="Office">
+      <a:majorFont>
+        <a:latin typeface="Aptos Display" panose="02110004020202020204"/>
+        <a:ea typeface=""/>
+        <a:cs typeface=""/>
+        <a:font script="Jpan" typeface="游ゴシック Light"/>
+        <a:font script="Hang" typeface="맑은 고딕"/>
+        <a:font script="Hans" typeface="等线 Light"/>
+        <a:font script="Hant" typeface="新細明體"/>
+        <a:font script="Arab" typeface="Times New Roman"/>
+        <a:font script="Hebr" typeface="Times New Roman"/>
+        <a:font script="Thai" typeface="Angsana New"/>
+        <a:font script="Ethi" typeface="Nyala"/>
+        <a:font script="Beng" typeface="Vrinda"/>
+        <a:font script="Gujr" typeface="Shruti"/>
+        <a:font script="Khmr" typeface="MoolBoran"/>
+        <a:font script="Knda" typeface="Tunga"/>
+        <a:font script="Guru" typeface="Raavi"/>
+        <a:font script="Cans" typeface="Euphemia"/>
+        <a:font script="Cher" typeface="Plantagenet Cherokee"/>
+        <a:font script="Yiii" typeface="Microsoft Yi Baiti"/>
+        <a:font script="Tibt" typeface="Microsoft Himalaya"/>
+        <a:font script="Thaa" typeface="MV Boli"/>
+        <a:font script="Deva" typeface="Mangal"/>
+        <a:font script="Telu" typeface="Gautami"/>
+        <a:font script="Taml" typeface="Latha"/>
+        <a:font script="Syrc" typeface="Estrangelo Edessa"/>
+        <a:font script="Orya" typeface="Kalinga"/>
+        <a:font script="Mlym" typeface="Kartika"/>
+        <a:font script="Laoo" typeface="DokChampa"/>
+        <a:font script="Sinh" typeface="Iskoola Pota"/>
+        <a:font script="Mong" typeface="Mongolian Baiti"/>
+        <a:font script="Viet" typeface="Times New Roman"/>
+        <a:font script="Uigh" typeface="Microsoft Uighur"/>
+        <a:font script="Geor" typeface="Sylfaen"/>
+        <a:font script="Armn" typeface="Arial"/>
+        <a:font script="Bugi" typeface="Leelawadee UI"/>
+        <a:font script="Bopo" typeface="Microsoft JhengHei"/>
+        <a:font script="Java" typeface="Javanese Text"/>
+        <a:font script="Lisu" typeface="Segoe UI"/>
+        <a:font script="Mymr" typeface="Myanmar Text"/>
+        <a:font script="Nkoo" typeface="Ebrima"/>
+        <a:font script="Olck" typeface="Nirmala UI"/>
+        <a:font script="Osma" typeface="Ebrima"/>
+        <a:font script="Phag" typeface="Phagspa"/>
+        <a:font script="Syrn" typeface="Estrangelo Edessa"/>
+        <a:font script="Syrj" typeface="Estrangelo Edessa"/>
+        <a:font script="Syre" typeface="Estrangelo Edessa"/>
+        <a:font script="Sora" typeface="Nirmala UI"/>
+        <a:font script="Tale" typeface="Microsoft Tai Le"/>
+        <a:font script="Talu" typeface="Microsoft New Tai Lue"/>
+        <a:font script="Tfng" typeface="Ebrima"/>
+      </a:majorFont>
+      <a:minorFont>
+        <a:latin typeface="Aptos" panose="02110004020202020204"/>
+        <a:ea typeface=""/>
+        <a:cs typeface=""/>
+        <a:font script="Jpan" typeface="游ゴシック"/>
+        <a:font script="Hang" typeface="맑은 고딕"/>
+        <a:font script="Hans" typeface="等线"/>
+        <a:font script="Hant" typeface="新細明體"/>
+        <a:font script="Arab" typeface="Arial"/>
+        <a:font script="Hebr" typeface="Arial"/>
+        <a:font script="Thai" typeface="Cordia New"/>
+        <a:font script="Ethi" typeface="Nyala"/>
+        <a:font script="Beng" typeface="Vrinda"/>
+        <a:font script="Gujr" typeface="Shruti"/>
+        <a:font script="Khmr" typeface="DaunPenh"/>
+        <a:font script="Knda" typeface="Tunga"/>
+        <a:font script="Guru" typeface="Raavi"/>
+        <a:font script="Cans" typeface="Euphemia"/>
+        <a:font script="Cher" typeface="Plantagenet Cherokee"/>
+        <a:font script="Yiii" typeface="Microsoft Yi Baiti"/>
+        <a:font script="Tibt" typeface="Microsoft Himalaya"/>
+        <a:font script="Thaa" typeface="MV Boli"/>
+        <a:font script="Deva" typeface="Mangal"/>
+        <a:font script="Telu" typeface="Gautami"/>
+        <a:font script="Taml" typeface="Latha"/>
+        <a:font script="Syrc" typeface="Estrangelo Edessa"/>
+        <a:font script="Orya" typeface="Kalinga"/>
+        <a:font script="Mlym" typeface="Kartika"/>
+        <a:font script="Laoo" typeface="DokChampa"/>
+        <a:font script="Sinh" typeface="Iskoola Pota"/>
+        <a:font script="Mong" typeface="Mongolian Baiti"/>
+        <a:font script="Viet" typeface="Arial"/>
+        <a:font script="Uigh" typeface="Microsoft Uighur"/>
+        <a:font script="Geor" typeface="Sylfaen"/>
+        <a:font script="Armn" typeface="Arial"/>
+        <a:font script="Bugi" typeface="Leelawadee UI"/>
+        <a:font script="Bopo" typeface="Microsoft JhengHei"/>
+        <a:font script="Java" typeface="Javanese Text"/>
+        <a:font script="Lisu" typeface="Segoe UI"/>
+        <a:font script="Mymr" typeface="Myanmar Text"/>
+        <a:font script="Nkoo" typeface="Ebrima"/>
+        <a:font script="Olck" typeface="Nirmala UI"/>
+        <a:font script="Osma" typeface="Ebrima"/>
+        <a:font script="Phag" typeface="Phagspa"/>
+        <a:font script="Syrn" typeface="Estrangelo Edessa"/>
+        <a:font script="Syrj" typeface="Estrangelo Edessa"/>
+        <a:font script="Syre" typeface="Estrangelo Edessa"/>
+        <a:font script="Sora" typeface="Nirmala UI"/>
+        <a:font script="Tale" typeface="Microsoft Tai Le"/>
+        <a:font script="Talu" typeface="Microsoft New Tai Lue"/>
+        <a:font script="Tfng" typeface="Ebrima"/>
+      </a:minorFont>
+    </a:fontScheme>
+    <a:fmtScheme name="Office">
+      <a:fillStyleLst>
+        <a:solidFill>
+          <a:schemeClr val="phClr"/>
+        </a:solidFill>
+        <a:gradFill rotWithShape="1">
+          <a:gsLst>
+            <a:gs pos="0">
+              <a:schemeClr val="phClr">
+                <a:lumMod val="110000"/>
+                <a:satMod val="105000"/>
+                <a:tint val="67000"/>
+              </a:schemeClr>
+            </a:gs>
+            <a:gs pos="50000">
+              <a:schemeClr val="phClr">
+                <a:lumMod val="105000"/>
+                <a:satMod val="103000"/>
+                <a:tint val="73000"/>
+              </a:schemeClr>
+            </a:gs>
+            <a:gs pos="100000">
+              <a:schemeClr val="phClr">
+                <a:lumMod val="105000"/>
+                <a:satMod val="109000"/>
+                <a:tint val="81000"/>
+              </a:schemeClr>
+            </a:gs>
+          </a:gsLst>
+          <a:lin ang="5400000" scaled="0"/>
+        </a:gradFill>
+        <a:gradFill rotWithShape="1">
+          <a:gsLst>
+            <a:gs pos="0">
+              <a:schemeClr val="phClr">
+                <a:satMod val="103000"/>
+                <a:lumMod val="102000"/>
+                <a:tint val="94000"/>
+              </a:schemeClr>
+            </a:gs>
+            <a:gs pos="50000">
+              <a:schemeClr val="phClr">
+                <a:satMod val="110000"/>
+                <a:lumMod val="100000"/>
+                <a:shade val="100000"/>
+              </a:schemeClr>
+            </a:gs>
+            <a:gs pos="100000">
+              <a:schemeClr val="phClr">
+                <a:lumMod val="99000"/>
+                <a:satMod val="120000"/>
+                <a:shade val="78000"/>
+              </a:schemeClr>
+            </a:gs>
+          </a:gsLst>
+          <a:lin ang="5400000" scaled="0"/>
+        </a:gradFill>
+      </a:fillStyleLst>
+      <a:lnStyleLst>
+        <a:ln w="12700" cap="flat" cmpd="sng" algn="ctr">
+          <a:solidFill>
+            <a:schemeClr val="phClr"/>
+          </a:solidFill>
+          <a:prstDash val="solid"/>
+          <a:miter lim="800000"/>
+        </a:ln>
+        <a:ln w="19050" cap="flat" cmpd="sng" algn="ctr">
+          <a:solidFill>
+            <a:schemeClr val="phClr"/>
+          </a:solidFill>
+          <a:prstDash val="solid"/>
+          <a:miter lim="800000"/>
+        </a:ln>
+        <a:ln w="25400" cap="flat" cmpd="sng" algn="ctr">
+          <a:solidFill>
+            <a:schemeClr val="phClr"/>
+          </a:solidFill>
+          <a:prstDash val="solid"/>
+          <a:miter lim="800000"/>
+        </a:ln>
+      </a:lnStyleLst>
+      <a:effectStyleLst>
+        <a:effectStyle>
+          <a:effectLst/>
+        </a:effectStyle>
+        <a:effectStyle>
+          <a:effectLst/>
+        </a:effectStyle>
+        <a:effectStyle>
+          <a:effectLst>
+            <a:outerShdw blurRad="57150" dist="19050" dir="5400000" algn="ctr" rotWithShape="0">
+              <a:srgbClr val="000000">
+                <a:alpha val="63000"/>
+              </a:srgbClr>
+            </a:outerShdw>
+          </a:effectLst>
+        </a:effectStyle>
+      </a:effectStyleLst>
+      <a:bgFillStyleLst>
+        <a:solidFill>
+          <a:schemeClr val="phClr"/>
+        </a:solidFill>
+        <a:solidFill>
+          <a:schemeClr val="phClr">
+            <a:tint val="95000"/>
+            <a:satMod val="170000"/>
+          </a:schemeClr>
+        </a:solidFill>
+        <a:gradFill rotWithShape="1">
+          <a:gsLst>
+            <a:gs pos="0">
+              <a:schemeClr val="phClr">
+                <a:tint val="93000"/>
+                <a:satMod val="150000"/>
+                <a:shade val="98000"/>
+                <a:lumMod val="102000"/>
+              </a:schemeClr>
+            </a:gs>
+            <a:gs pos="50000">
+              <a:schemeClr val="phClr">
+                <a:tint val="98000"/>
+                <a:satMod val="130000"/>
+                <a:shade val="90000"/>
+                <a:lumMod val="103000"/>
+              </a:schemeClr>
+            </a:gs>
+            <a:gs pos="100000">
+              <a:schemeClr val="phClr">
+                <a:shade val="63000"/>
+                <a:satMod val="120000"/>
+              </a:schemeClr>
+            </a:gs>
+          </a:gsLst>
+          <a:lin ang="5400000" scaled="0"/>
+        </a:gradFill>
+      </a:bgFillStyleLst>
+    </a:fmtScheme>
+  </a:themeElements>
+  <a:objectDefaults>
+    <a:lnDef>
+      <a:spPr/>
+      <a:bodyPr/>
+      <a:lstStyle/>
+      <a:style>
+        <a:lnRef idx="2">
+          <a:schemeClr val="accent1"/>
+        </a:lnRef>
+        <a:fillRef idx="0">
+          <a:schemeClr val="accent1"/>
+        </a:fillRef>
+        <a:effectRef idx="1">
+          <a:schemeClr val="accent1"/>
+        </a:effectRef>
+        <a:fontRef idx="minor">
+          <a:schemeClr val="tx1"/>
+        </a:fontRef>
+      </a:style>
+    </a:lnDef>
+  </a:objectDefaults>
+  <a:extraClrSchemeLst/>
+  <a:extLst>
+    <a:ext uri="{05A4C25C-085E-4340-85A3-A5531E510DB2}">
+      <thm15:themeFamily xmlns:thm15="http://schemas.microsoft.com/office/thememl/2012/main" name="Office Theme" id="{2E142A2C-CD16-42D6-873A-C26D2A0506FA}" vid="{1BDDFF52-6CD6-40A5-AB3C-68EB2F1E4D0A}"/>
+    </a:ext>
+  </a:extLst>
+</a:theme>
 </file>
</xml_diff>